<commit_message>
docs: update PowerPoint presentation with notebook-based Grad-CAM and app info
</commit_message>
<xml_diff>
--- a/Brain_Tumor_Detection_Presentation.pptx
+++ b/Brain_Tumor_Detection_Presentation.pptx
@@ -3287,7 +3287,7 @@
               </a:defRPr>
             </a:pPr>
             <a:r>
-              <a:t>1) Ragyari Sruthi (Roll No: 23781A33D5) - Dept. of CSE (AI &amp; ML)</a:t>
+              <a:t>1) Ragyari Sruthi (Roll No: 23781A33D5) — Dept. of CSE (AI &amp; ML)</a:t>
             </a:r>
           </a:p>
           <a:p>
@@ -3303,7 +3303,7 @@
               </a:defRPr>
             </a:pPr>
             <a:r>
-              <a:t>2) Ratala Venkata Ramakrishna (Roll No: 23781A33D7) - Dept. of CSE (AI &amp; ML)</a:t>
+              <a:t>2) Ratala Venkata Ramakrishna (Roll No: 23781A33D7) — Dept. of CSE (AI &amp; ML)</a:t>
             </a:r>
           </a:p>
           <a:p>
@@ -3319,7 +3319,7 @@
               </a:defRPr>
             </a:pPr>
             <a:r>
-              <a:t>3) Shaik Thameem (Roll No: 23781A33F3) - Dept. of CSE (AI &amp; ML)</a:t>
+              <a:t>3) Shaik Thameem (Roll No: 23781A33F3) — Dept. of CSE (AI &amp; ML)</a:t>
             </a:r>
           </a:p>
           <a:p>
@@ -3519,7 +3519,7 @@
                   <a:srgbClr val="003366"/>
                 </a:solidFill>
               </a:rPr>
-              <a:t>Deployment Choice:</a:t>
+              <a:t>Deployment:</a:t>
             </a:r>
             <a:r>
               <a:rPr>
@@ -3577,7 +3577,7 @@
                   <a:srgbClr val="3C3C3C"/>
                 </a:solidFill>
               </a:rPr>
-              <a:t>, which generates a clean, responsive web interface natively in Python.</a:t>
+              <a:t> for a clean, responsive layout.</a:t>
             </a:r>
           </a:p>
           <a:p>
@@ -3627,7 +3627,7 @@
                   <a:srgbClr val="3C3C3C"/>
                 </a:solidFill>
               </a:rPr>
-              <a:t>, loading instantly and serving predictions on CPU in milliseconds.</a:t>
+              <a:t>, running on CPU with millisecond response time.</a:t>
             </a:r>
           </a:p>
           <a:p>
@@ -3679,7 +3679,7 @@
                   <a:srgbClr val="3C3C3C"/>
                 </a:solidFill>
               </a:rPr>
-              <a:t>  1. Drag &amp; drop a brain MRI scan (.jpg/.png) into the app.</a:t>
+              <a:t>  1. Upload a brain MRI scan (.jpg/.png).</a:t>
             </a:r>
           </a:p>
           <a:p>
@@ -3715,7 +3715,7 @@
                   <a:srgbClr val="3C3C3C"/>
                 </a:solidFill>
               </a:rPr>
-              <a:t>  3. View the predicted tumor category and confidence scores.</a:t>
+              <a:t>  3. View the predicted tumor category with a confidence score breakdown across all four classes.</a:t>
             </a:r>
           </a:p>
           <a:p>
@@ -3733,7 +3733,7 @@
                   <a:srgbClr val="3C3C3C"/>
                 </a:solidFill>
               </a:rPr>
-              <a:t>  4. Examine the Grad-CAM heatmap visualization overlay.</a:t>
+              <a:t>  4. Read a short clinical description of the predicted class.</a:t>
             </a:r>
           </a:p>
         </p:txBody>
@@ -3949,7 +3949,7 @@
                   <a:srgbClr val="3C3C3C"/>
                 </a:solidFill>
               </a:rPr>
-              <a:t> Gradient-weighted Class Activation Mapping computes heatmaps showing which regions in the MRI image the model focused on.</a:t>
+              <a:t> Gradient-weighted Class Activation Mapping computes heatmaps showing which regions of the MRI the model focused on for its prediction.</a:t>
             </a:r>
           </a:p>
           <a:p>
@@ -3975,6 +3975,40 @@
                   <a:srgbClr val="003366"/>
                 </a:solidFill>
               </a:rPr>
+              <a:t>Where it was used:</a:t>
+            </a:r>
+            <a:r>
+              <a:rPr>
+                <a:solidFill>
+                  <a:srgbClr val="3C3C3C"/>
+                </a:solidFill>
+              </a:rPr>
+              <a:t> Implemented and validated during model development in the training notebook, using the final convolutional layer (`top_conv`) of the EfficientNetB0 backbone.</a:t>
+            </a:r>
+          </a:p>
+          <a:p>
+            <a:pPr>
+              <a:spcBef>
+                <a:spcPts val="800"/>
+              </a:spcBef>
+              <a:defRPr sz="1400">
+                <a:latin typeface="Calibri"/>
+              </a:defRPr>
+            </a:pPr>
+            <a:r>
+              <a:rPr>
+                <a:solidFill>
+                  <a:srgbClr val="3C3C3C"/>
+                </a:solidFill>
+              </a:rPr>
+              <a:t/>
+            </a:r>
+            <a:r>
+              <a:rPr b="1">
+                <a:solidFill>
+                  <a:srgbClr val="003366"/>
+                </a:solidFill>
+              </a:rPr>
               <a:t>Clinical Significance:</a:t>
             </a:r>
             <a:r>
@@ -3983,7 +4017,7 @@
                   <a:srgbClr val="3C3C3C"/>
                 </a:solidFill>
               </a:rPr>
-              <a:t> Explains the 'black-box' decisions of deep learning. Radiologists can visually verify if the model is focusing on actual tumor boundaries or image artifacts.</a:t>
+              <a:t> Lets a radiologist visually confirm the model is attending to the actual tumor region rather than irrelevant background, building trust before deployment.</a:t>
             </a:r>
           </a:p>
           <a:p>
@@ -4009,49 +4043,15 @@
                   <a:srgbClr val="003366"/>
                 </a:solidFill>
               </a:rPr>
-              <a:t>Methodology:</a:t>
-            </a:r>
-            <a:r>
-              <a:rPr>
-                <a:solidFill>
-                  <a:srgbClr val="3C3C3C"/>
-                </a:solidFill>
-              </a:rPr>
-              <a:t> Computes gradients of the score for class $c$ with respect to feature map activations of the final convolutional layer (`top_conv` layer of EfficientNetB0).</a:t>
-            </a:r>
-          </a:p>
-          <a:p>
-            <a:pPr>
-              <a:spcBef>
-                <a:spcPts val="800"/>
-              </a:spcBef>
-              <a:defRPr sz="1400">
-                <a:latin typeface="Calibri"/>
-              </a:defRPr>
-            </a:pPr>
-            <a:r>
-              <a:rPr>
-                <a:solidFill>
-                  <a:srgbClr val="3C3C3C"/>
-                </a:solidFill>
-              </a:rPr>
-              <a:t/>
-            </a:r>
-            <a:r>
-              <a:rPr b="1">
-                <a:solidFill>
-                  <a:srgbClr val="003366"/>
-                </a:solidFill>
-              </a:rPr>
-              <a:t>Superimposition:</a:t>
-            </a:r>
-            <a:r>
-              <a:rPr>
-                <a:solidFill>
-                  <a:srgbClr val="3C3C3C"/>
-                </a:solidFill>
-              </a:rPr>
-              <a:t> The resulting raw heatmap is converted to RGB jet-color, upsampled to $224 	imes 224$, and blended with the original grayscale MRI.</a:t>
+              <a:t>Note:</a:t>
+            </a:r>
+            <a:r>
+              <a:rPr>
+                <a:solidFill>
+                  <a:srgbClr val="3C3C3C"/>
+                </a:solidFill>
+              </a:rPr>
+              <a:t> This visualization currently runs in the training/analysis notebook; integrating it directly into the live web app is planned as future work.</a:t>
             </a:r>
           </a:p>
         </p:txBody>
@@ -4239,7 +4239,7 @@
           <a:p>
             <a:pPr>
               <a:spcBef>
-                <a:spcPts val="1000"/>
+                <a:spcPts val="800"/>
               </a:spcBef>
               <a:defRPr sz="1500">
                 <a:latin typeface="Calibri"/>
@@ -4259,21 +4259,21 @@
                   <a:srgbClr val="003366"/>
                 </a:solidFill>
               </a:rPr>
-              <a:t>End-to-End Delivery:</a:t>
-            </a:r>
-            <a:r>
-              <a:rPr>
-                <a:solidFill>
-                  <a:srgbClr val="3C3C3C"/>
-                </a:solidFill>
-              </a:rPr>
-              <a:t> Successfully engineered a complete deep learning pipeline—from programmatically downloading the dataset to deploying a live clinical-support web application.</a:t>
-            </a:r>
-          </a:p>
-          <a:p>
-            <a:pPr>
-              <a:spcBef>
-                <a:spcPts val="1000"/>
+              <a:t>End-to-End Pipeline:</a:t>
+            </a:r>
+            <a:r>
+              <a:rPr>
+                <a:solidFill>
+                  <a:srgbClr val="3C3C3C"/>
+                </a:solidFill>
+              </a:rPr>
+              <a:t> Successfully built and delivered a complete pipeline from automated dataset download to deployed web application.</a:t>
+            </a:r>
+          </a:p>
+          <a:p>
+            <a:pPr>
+              <a:spcBef>
+                <a:spcPts val="800"/>
               </a:spcBef>
               <a:defRPr sz="1500">
                 <a:latin typeface="Calibri"/>
@@ -4301,13 +4301,45 @@
                   <a:srgbClr val="3C3C3C"/>
                 </a:solidFill>
               </a:rPr>
-              <a:t> Demonstrated that EfficientNetB0 transfer learning is highly suited for medical classification tasks, achieving 99%+ accuracy.</a:t>
-            </a:r>
-          </a:p>
-          <a:p>
-            <a:pPr>
-              <a:spcBef>
-                <a:spcPts val="1000"/>
+              <a:t> EfficientNetB0 transfer learning achieved </a:t>
+            </a:r>
+            <a:r>
+              <a:rPr b="1">
+                <a:solidFill>
+                  <a:srgbClr val="003366"/>
+                </a:solidFill>
+              </a:rPr>
+              <a:t>99.59%</a:t>
+            </a:r>
+            <a:r>
+              <a:rPr>
+                <a:solidFill>
+                  <a:srgbClr val="3C3C3C"/>
+                </a:solidFill>
+              </a:rPr>
+              <a:t> accuracy on tumor cases and </a:t>
+            </a:r>
+            <a:r>
+              <a:rPr b="1">
+                <a:solidFill>
+                  <a:srgbClr val="003366"/>
+                </a:solidFill>
+              </a:rPr>
+              <a:t>99.99%</a:t>
+            </a:r>
+            <a:r>
+              <a:rPr>
+                <a:solidFill>
+                  <a:srgbClr val="3C3C3C"/>
+                </a:solidFill>
+              </a:rPr>
+              <a:t> on healthy cases after resolving a critical preprocessing bug.</a:t>
+            </a:r>
+          </a:p>
+          <a:p>
+            <a:pPr>
+              <a:spcBef>
+                <a:spcPts val="800"/>
               </a:spcBef>
               <a:defRPr sz="1500">
                 <a:latin typeface="Calibri"/>
@@ -4327,21 +4359,21 @@
                   <a:srgbClr val="003366"/>
                 </a:solidFill>
               </a:rPr>
-              <a:t>Technical Debugging:</a:t>
-            </a:r>
-            <a:r>
-              <a:rPr>
-                <a:solidFill>
-                  <a:srgbClr val="3C3C3C"/>
-                </a:solidFill>
-              </a:rPr>
-              <a:t> Successfully resolved a critical preprocessing scaling bug that had caused total training collapse, reinforcing the importance of input pipeline audits in ML.</a:t>
-            </a:r>
-          </a:p>
-          <a:p>
-            <a:pPr>
-              <a:spcBef>
-                <a:spcPts val="1000"/>
+              <a:t>Validated Explainability:</a:t>
+            </a:r>
+            <a:r>
+              <a:rPr>
+                <a:solidFill>
+                  <a:srgbClr val="3C3C3C"/>
+                </a:solidFill>
+              </a:rPr>
+              <a:t> Grad-CAM explainability was developed and validated in the training notebook to support model trust.</a:t>
+            </a:r>
+          </a:p>
+          <a:p>
+            <a:pPr>
+              <a:spcBef>
+                <a:spcPts val="800"/>
               </a:spcBef>
               <a:defRPr sz="1500">
                 <a:latin typeface="Calibri"/>
@@ -4361,21 +4393,21 @@
                   <a:srgbClr val="003366"/>
                 </a:solidFill>
               </a:rPr>
-              <a:t>Clinical Support Capability:</a:t>
-            </a:r>
-            <a:r>
-              <a:rPr>
-                <a:solidFill>
-                  <a:srgbClr val="3C3C3C"/>
-                </a:solidFill>
-              </a:rPr>
-              <a:t> Integrated Grad-CAM explainability and deployed a lightweight CPU-run application, demonstrating the practicality of deploying lightweight neural nets in resource-constrained environments.</a:t>
-            </a:r>
-          </a:p>
-          <a:p>
-            <a:pPr>
-              <a:spcBef>
-                <a:spcPts val="1000"/>
+              <a:t>Lightweight Deployment:</a:t>
+            </a:r>
+            <a:r>
+              <a:rPr>
+                <a:solidFill>
+                  <a:srgbClr val="3C3C3C"/>
+                </a:solidFill>
+              </a:rPr>
+              <a:t> Deployed a lightweight, CPU-run Gradio app on Hugging Face Spaces using ONNX Runtime.</a:t>
+            </a:r>
+          </a:p>
+          <a:p>
+            <a:pPr>
+              <a:spcBef>
+                <a:spcPts val="800"/>
               </a:spcBef>
               <a:defRPr sz="1500">
                 <a:latin typeface="Calibri"/>
@@ -4403,7 +4435,61 @@
                   <a:srgbClr val="3C3C3C"/>
                 </a:solidFill>
               </a:rPr>
-              <a:t> Plan to expand this system to classify more tumor subtypes and integrate segmentation models like U-Net for tumor volume quantification.</a:t>
+              <a:t/>
+            </a:r>
+          </a:p>
+          <a:p>
+            <a:pPr>
+              <a:spcBef>
+                <a:spcPts val="800"/>
+              </a:spcBef>
+              <a:defRPr sz="1300">
+                <a:latin typeface="Calibri"/>
+              </a:defRPr>
+            </a:pPr>
+            <a:r>
+              <a:rPr>
+                <a:solidFill>
+                  <a:srgbClr val="3C3C3C"/>
+                </a:solidFill>
+              </a:rPr>
+              <a:t>  - Integrate live Grad-CAM heatmap visualization directly into the deployed web application.</a:t>
+            </a:r>
+          </a:p>
+          <a:p>
+            <a:pPr>
+              <a:spcBef>
+                <a:spcPts val="800"/>
+              </a:spcBef>
+              <a:defRPr sz="1300">
+                <a:latin typeface="Calibri"/>
+              </a:defRPr>
+            </a:pPr>
+            <a:r>
+              <a:rPr>
+                <a:solidFill>
+                  <a:srgbClr val="3C3C3C"/>
+                </a:solidFill>
+              </a:rPr>
+              <a:t>  - Expand the classification model to more brain tumor subtypes.</a:t>
+            </a:r>
+          </a:p>
+          <a:p>
+            <a:pPr>
+              <a:spcBef>
+                <a:spcPts val="800"/>
+              </a:spcBef>
+              <a:defRPr sz="1300">
+                <a:latin typeface="Calibri"/>
+              </a:defRPr>
+            </a:pPr>
+            <a:r>
+              <a:rPr>
+                <a:solidFill>
+                  <a:srgbClr val="3C3C3C"/>
+                </a:solidFill>
+              </a:rPr>
+              <a:t>  - Add U-Net segmentation models for tumor volume quantification.</a:t>
             </a:r>
           </a:p>
         </p:txBody>
@@ -4932,7 +5018,7 @@
                   <a:srgbClr val="3C3C3C"/>
                 </a:solidFill>
               </a:rPr>
-              <a:t> Deployed as a web application using Gradio on Hugging Face Spaces for real-time inference.</a:t>
+              <a:t> Deployed as a web application using Gradio on Hugging Face Spaces for real-time predictions.</a:t>
             </a:r>
           </a:p>
           <a:p>

</xml_diff>

<commit_message>
docs: finalize PowerPoint presentation with clean image captions and removed Q&A
</commit_message>
<xml_diff>
--- a/Brain_Tumor_Detection_Presentation.pptx
+++ b/Brain_Tumor_Detection_Presentation.pptx
@@ -3738,9 +3738,45 @@
           </a:p>
         </p:txBody>
       </p:sp>
+      <p:sp>
+        <p:nvSpPr>
+          <p:cNvPr id="6" name="TextBox 5"/>
+          <p:cNvSpPr txBox="1"/>
+          <p:nvPr/>
+        </p:nvSpPr>
+        <p:spPr>
+          <a:xfrm>
+            <a:off x="5943600" y="1188720"/>
+            <a:ext cx="5486400" cy="365760"/>
+          </a:xfrm>
+          <a:prstGeom prst="rect">
+            <a:avLst/>
+          </a:prstGeom>
+          <a:noFill/>
+        </p:spPr>
+        <p:txBody>
+          <a:bodyPr wrap="none">
+            <a:spAutoFit/>
+          </a:bodyPr>
+          <a:lstStyle/>
+          <a:p>
+            <a:pPr algn="ctr">
+              <a:defRPr sz="1300" b="1">
+                <a:solidFill>
+                  <a:srgbClr val="003366"/>
+                </a:solidFill>
+                <a:latin typeface="Arial"/>
+              </a:defRPr>
+            </a:pPr>
+            <a:r>
+              <a:t>Live Gradio Web Interface on Hugging Face Spaces</a:t>
+            </a:r>
+          </a:p>
+        </p:txBody>
+      </p:sp>
       <p:pic>
         <p:nvPicPr>
-          <p:cNvPr id="6" name="Picture 5" descr="hf_space_status_1782152116076.png"/>
+          <p:cNvPr id="7" name="Picture 6" descr="hf_space_status_1782152116076.png"/>
           <p:cNvPicPr>
             <a:picLocks noChangeAspect="1"/>
           </p:cNvPicPr>
@@ -3754,8 +3790,8 @@
         </p:blipFill>
         <p:spPr>
           <a:xfrm>
-            <a:off x="5943600" y="1371600"/>
-            <a:ext cx="5486400" cy="4114800"/>
+            <a:off x="5943600" y="1554480"/>
+            <a:ext cx="5486400" cy="3931920"/>
           </a:xfrm>
           <a:prstGeom prst="rect">
             <a:avLst/>
@@ -4056,9 +4092,45 @@
           </a:p>
         </p:txBody>
       </p:sp>
+      <p:sp>
+        <p:nvSpPr>
+          <p:cNvPr id="6" name="TextBox 5"/>
+          <p:cNvSpPr txBox="1"/>
+          <p:nvPr/>
+        </p:nvSpPr>
+        <p:spPr>
+          <a:xfrm>
+            <a:off x="6217920" y="1188720"/>
+            <a:ext cx="5212080" cy="365760"/>
+          </a:xfrm>
+          <a:prstGeom prst="rect">
+            <a:avLst/>
+          </a:prstGeom>
+          <a:noFill/>
+        </p:spPr>
+        <p:txBody>
+          <a:bodyPr wrap="none">
+            <a:spAutoFit/>
+          </a:bodyPr>
+          <a:lstStyle/>
+          <a:p>
+            <a:pPr algn="ctr">
+              <a:defRPr sz="1300" b="1">
+                <a:solidFill>
+                  <a:srgbClr val="003366"/>
+                </a:solidFill>
+                <a:latin typeface="Arial"/>
+              </a:defRPr>
+            </a:pPr>
+            <a:r>
+              <a:t>Notebook-Generated Grad-CAM Heatmaps</a:t>
+            </a:r>
+          </a:p>
+        </p:txBody>
+      </p:sp>
       <p:pic>
         <p:nvPicPr>
-          <p:cNvPr id="6" name="Picture 5" descr="gradcam_results.png"/>
+          <p:cNvPr id="7" name="Picture 6" descr="gradcam_results.png"/>
           <p:cNvPicPr>
             <a:picLocks noChangeAspect="1"/>
           </p:cNvPicPr>
@@ -4072,8 +4144,8 @@
         </p:blipFill>
         <p:spPr>
           <a:xfrm>
-            <a:off x="6217920" y="1371600"/>
-            <a:ext cx="5212080" cy="4572000"/>
+            <a:off x="6217920" y="1554480"/>
+            <a:ext cx="5212080" cy="4389120"/>
           </a:xfrm>
           <a:prstGeom prst="rect">
             <a:avLst/>
@@ -4563,7 +4635,7 @@
         </p:nvSpPr>
         <p:spPr>
           <a:xfrm>
-            <a:off x="1828800" y="2011680"/>
+            <a:off x="1828800" y="2286000"/>
             <a:ext cx="8534095" cy="2743200"/>
           </a:xfrm>
           <a:prstGeom prst="rect">
@@ -4592,25 +4664,9 @@
           <a:p>
             <a:pPr algn="ctr">
               <a:spcBef>
-                <a:spcPts val="2000"/>
-              </a:spcBef>
-              <a:defRPr sz="2800">
-                <a:solidFill>
-                  <a:srgbClr val="E6F0FF"/>
-                </a:solidFill>
-                <a:latin typeface="Calibri"/>
-              </a:defRPr>
-            </a:pPr>
-            <a:r>
-              <a:t>Questions &amp; Answers</a:t>
-            </a:r>
-          </a:p>
-          <a:p>
-            <a:pPr algn="ctr">
-              <a:spcBef>
-                <a:spcPts val="3000"/>
-              </a:spcBef>
-              <a:defRPr sz="1400">
+                <a:spcPts val="4000"/>
+              </a:spcBef>
+              <a:defRPr sz="1500">
                 <a:solidFill>
                   <a:srgbClr val="E6F0FF"/>
                 </a:solidFill>
@@ -6269,9 +6325,45 @@
           </a:p>
         </p:txBody>
       </p:sp>
+      <p:sp>
+        <p:nvSpPr>
+          <p:cNvPr id="6" name="TextBox 5"/>
+          <p:cNvSpPr txBox="1"/>
+          <p:nvPr/>
+        </p:nvSpPr>
+        <p:spPr>
+          <a:xfrm>
+            <a:off x="6217920" y="1188720"/>
+            <a:ext cx="5212080" cy="365760"/>
+          </a:xfrm>
+          <a:prstGeom prst="rect">
+            <a:avLst/>
+          </a:prstGeom>
+          <a:noFill/>
+        </p:spPr>
+        <p:txBody>
+          <a:bodyPr wrap="none">
+            <a:spAutoFit/>
+          </a:bodyPr>
+          <a:lstStyle/>
+          <a:p>
+            <a:pPr algn="ctr">
+              <a:defRPr sz="1400" b="1">
+                <a:solidFill>
+                  <a:srgbClr val="003366"/>
+                </a:solidFill>
+                <a:latin typeface="Arial"/>
+              </a:defRPr>
+            </a:pPr>
+            <a:r>
+              <a:t>Sample Brain MRI Scans per Class</a:t>
+            </a:r>
+          </a:p>
+        </p:txBody>
+      </p:sp>
       <p:pic>
         <p:nvPicPr>
-          <p:cNvPr id="6" name="Picture 5" descr="sample_images.png"/>
+          <p:cNvPr id="7" name="Picture 6" descr="sample_images.png"/>
           <p:cNvPicPr>
             <a:picLocks noChangeAspect="1"/>
           </p:cNvPicPr>
@@ -6285,8 +6377,8 @@
         </p:blipFill>
         <p:spPr>
           <a:xfrm>
-            <a:off x="6217920" y="1371600"/>
-            <a:ext cx="5212080" cy="4572000"/>
+            <a:off x="6217920" y="1645920"/>
+            <a:ext cx="5212080" cy="4297680"/>
           </a:xfrm>
           <a:prstGeom prst="rect">
             <a:avLst/>
@@ -9030,9 +9122,45 @@
           </a:p>
         </p:txBody>
       </p:sp>
+      <p:sp>
+        <p:nvSpPr>
+          <p:cNvPr id="6" name="TextBox 5"/>
+          <p:cNvSpPr txBox="1"/>
+          <p:nvPr/>
+        </p:nvSpPr>
+        <p:spPr>
+          <a:xfrm>
+            <a:off x="6217920" y="1188720"/>
+            <a:ext cx="5212080" cy="274320"/>
+          </a:xfrm>
+          <a:prstGeom prst="rect">
+            <a:avLst/>
+          </a:prstGeom>
+          <a:noFill/>
+        </p:spPr>
+        <p:txBody>
+          <a:bodyPr wrap="none">
+            <a:spAutoFit/>
+          </a:bodyPr>
+          <a:lstStyle/>
+          <a:p>
+            <a:pPr algn="ctr">
+              <a:defRPr sz="1150" b="1">
+                <a:solidFill>
+                  <a:srgbClr val="003366"/>
+                </a:solidFill>
+                <a:latin typeface="Arial"/>
+              </a:defRPr>
+            </a:pPr>
+            <a:r>
+              <a:t>Model Training Curves (Loss &amp; Accuracy)</a:t>
+            </a:r>
+          </a:p>
+        </p:txBody>
+      </p:sp>
       <p:pic>
         <p:nvPicPr>
-          <p:cNvPr id="6" name="Picture 5" descr="training_curves.png"/>
+          <p:cNvPr id="7" name="Picture 6" descr="training_curves.png"/>
           <p:cNvPicPr>
             <a:picLocks noChangeAspect="1"/>
           </p:cNvPicPr>
@@ -9046,17 +9174,53 @@
         </p:blipFill>
         <p:spPr>
           <a:xfrm>
-            <a:off x="6217920" y="1371600"/>
-            <a:ext cx="5212080" cy="2194560"/>
+            <a:off x="6217920" y="1463040"/>
+            <a:ext cx="5212080" cy="2011680"/>
           </a:xfrm>
           <a:prstGeom prst="rect">
             <a:avLst/>
           </a:prstGeom>
         </p:spPr>
       </p:pic>
+      <p:sp>
+        <p:nvSpPr>
+          <p:cNvPr id="8" name="TextBox 7"/>
+          <p:cNvSpPr txBox="1"/>
+          <p:nvPr/>
+        </p:nvSpPr>
+        <p:spPr>
+          <a:xfrm>
+            <a:off x="6217920" y="3566160"/>
+            <a:ext cx="5212080" cy="274320"/>
+          </a:xfrm>
+          <a:prstGeom prst="rect">
+            <a:avLst/>
+          </a:prstGeom>
+          <a:noFill/>
+        </p:spPr>
+        <p:txBody>
+          <a:bodyPr wrap="none">
+            <a:spAutoFit/>
+          </a:bodyPr>
+          <a:lstStyle/>
+          <a:p>
+            <a:pPr algn="ctr">
+              <a:defRPr sz="1150" b="1">
+                <a:solidFill>
+                  <a:srgbClr val="003366"/>
+                </a:solidFill>
+                <a:latin typeface="Arial"/>
+              </a:defRPr>
+            </a:pPr>
+            <a:r>
+              <a:t>Test Set Confusion Matrix</a:t>
+            </a:r>
+          </a:p>
+        </p:txBody>
+      </p:sp>
       <p:pic>
         <p:nvPicPr>
-          <p:cNvPr id="7" name="Picture 6" descr="confusion_matrix.png"/>
+          <p:cNvPr id="9" name="Picture 8" descr="confusion_matrix.png"/>
           <p:cNvPicPr>
             <a:picLocks noChangeAspect="1"/>
           </p:cNvPicPr>
@@ -9070,8 +9234,8 @@
         </p:blipFill>
         <p:spPr>
           <a:xfrm>
-            <a:off x="6217920" y="3749039"/>
-            <a:ext cx="5212080" cy="2194560"/>
+            <a:off x="6217920" y="3840480"/>
+            <a:ext cx="5212080" cy="2011680"/>
           </a:xfrm>
           <a:prstGeom prst="rect">
             <a:avLst/>

</xml_diff>

<commit_message>
docs: increase font sizes and heading contrast for better presentation visibility
</commit_message>
<xml_diff>
--- a/Brain_Tumor_Detection_Presentation.pptx
+++ b/Brain_Tumor_Detection_Presentation.pptx
@@ -3109,7 +3109,7 @@
         <p:spPr>
           <a:xfrm>
             <a:off x="0" y="0"/>
-            <a:ext cx="365760" cy="6858000"/>
+            <a:ext cx="457200" cy="6858000"/>
           </a:xfrm>
           <a:prstGeom prst="rect">
             <a:avLst/>
@@ -3151,8 +3151,8 @@
         </p:nvSpPr>
         <p:spPr>
           <a:xfrm>
-            <a:off x="914400" y="1371600"/>
-            <a:ext cx="10332720" cy="2011680"/>
+            <a:off x="914400" y="1188720"/>
+            <a:ext cx="10332720" cy="2286000"/>
           </a:xfrm>
           <a:prstGeom prst="rect">
             <a:avLst/>
@@ -3166,7 +3166,7 @@
           <a:lstStyle/>
           <a:p>
             <a:pPr>
-              <a:defRPr sz="3600" b="1">
+              <a:defRPr sz="4000" b="1">
                 <a:solidFill>
                   <a:srgbClr val="003366"/>
                 </a:solidFill>
@@ -3180,9 +3180,9 @@
           <a:p>
             <a:pPr>
               <a:spcBef>
-                <a:spcPts val="1000"/>
-              </a:spcBef>
-              <a:defRPr sz="1800">
+                <a:spcPts val="1200"/>
+              </a:spcBef>
+              <a:defRPr sz="2200">
                 <a:solidFill>
                   <a:srgbClr val="4682B4"/>
                 </a:solidFill>
@@ -3204,7 +3204,7 @@
         <p:spPr>
           <a:xfrm>
             <a:off x="914400" y="3474720"/>
-            <a:ext cx="10332720" cy="36576"/>
+            <a:ext cx="10332720" cy="45720"/>
           </a:xfrm>
           <a:prstGeom prst="rect">
             <a:avLst/>
@@ -3263,71 +3263,71 @@
           <a:lstStyle/>
           <a:p>
             <a:pPr>
+              <a:defRPr sz="1600" b="1">
+                <a:solidFill>
+                  <a:srgbClr val="003366"/>
+                </a:solidFill>
+                <a:latin typeface="Calibri"/>
+              </a:defRPr>
+            </a:pPr>
+            <a:r>
+              <a:t>Presented By:</a:t>
+            </a:r>
+          </a:p>
+          <a:p>
+            <a:pPr>
+              <a:spcBef>
+                <a:spcPts val="400"/>
+              </a:spcBef>
+              <a:defRPr sz="1500">
+                <a:solidFill>
+                  <a:srgbClr val="323232"/>
+                </a:solidFill>
+                <a:latin typeface="Calibri"/>
+              </a:defRPr>
+            </a:pPr>
+            <a:r>
+              <a:t>1) Ragyari Sruthi (Roll No: 23781A33D5) — Dept. of CSE (AI &amp; ML)</a:t>
+            </a:r>
+          </a:p>
+          <a:p>
+            <a:pPr>
+              <a:spcBef>
+                <a:spcPts val="400"/>
+              </a:spcBef>
+              <a:defRPr sz="1500">
+                <a:solidFill>
+                  <a:srgbClr val="323232"/>
+                </a:solidFill>
+                <a:latin typeface="Calibri"/>
+              </a:defRPr>
+            </a:pPr>
+            <a:r>
+              <a:t>2) Ratala Venkata Ramakrishna (Roll No: 23781A33D7) — Dept. of CSE (AI &amp; ML)</a:t>
+            </a:r>
+          </a:p>
+          <a:p>
+            <a:pPr>
+              <a:spcBef>
+                <a:spcPts val="400"/>
+              </a:spcBef>
+              <a:defRPr sz="1500">
+                <a:solidFill>
+                  <a:srgbClr val="323232"/>
+                </a:solidFill>
+                <a:latin typeface="Calibri"/>
+              </a:defRPr>
+            </a:pPr>
+            <a:r>
+              <a:t>3) Shaik Thameem (Roll No: 23781A33F3) — Dept. of CSE (AI &amp; ML)</a:t>
+            </a:r>
+          </a:p>
+          <a:p>
+            <a:pPr>
+              <a:spcBef>
+                <a:spcPts val="1400"/>
+              </a:spcBef>
               <a:defRPr sz="1400" b="1">
-                <a:solidFill>
-                  <a:srgbClr val="3C3C3C"/>
-                </a:solidFill>
-                <a:latin typeface="Calibri"/>
-              </a:defRPr>
-            </a:pPr>
-            <a:r>
-              <a:t>Presented By:</a:t>
-            </a:r>
-          </a:p>
-          <a:p>
-            <a:pPr>
-              <a:spcBef>
-                <a:spcPts val="400"/>
-              </a:spcBef>
-              <a:defRPr sz="1300">
-                <a:solidFill>
-                  <a:srgbClr val="3C3C3C"/>
-                </a:solidFill>
-                <a:latin typeface="Calibri"/>
-              </a:defRPr>
-            </a:pPr>
-            <a:r>
-              <a:t>1) Ragyari Sruthi (Roll No: 23781A33D5) — Dept. of CSE (AI &amp; ML)</a:t>
-            </a:r>
-          </a:p>
-          <a:p>
-            <a:pPr>
-              <a:spcBef>
-                <a:spcPts val="400"/>
-              </a:spcBef>
-              <a:defRPr sz="1300">
-                <a:solidFill>
-                  <a:srgbClr val="3C3C3C"/>
-                </a:solidFill>
-                <a:latin typeface="Calibri"/>
-              </a:defRPr>
-            </a:pPr>
-            <a:r>
-              <a:t>2) Ratala Venkata Ramakrishna (Roll No: 23781A33D7) — Dept. of CSE (AI &amp; ML)</a:t>
-            </a:r>
-          </a:p>
-          <a:p>
-            <a:pPr>
-              <a:spcBef>
-                <a:spcPts val="400"/>
-              </a:spcBef>
-              <a:defRPr sz="1300">
-                <a:solidFill>
-                  <a:srgbClr val="3C3C3C"/>
-                </a:solidFill>
-                <a:latin typeface="Calibri"/>
-              </a:defRPr>
-            </a:pPr>
-            <a:r>
-              <a:t>3) Shaik Thameem (Roll No: 23781A33F3) — Dept. of CSE (AI &amp; ML)</a:t>
-            </a:r>
-          </a:p>
-          <a:p>
-            <a:pPr>
-              <a:spcBef>
-                <a:spcPts val="1200"/>
-              </a:spcBef>
-              <a:defRPr sz="1200" b="1">
                 <a:solidFill>
                   <a:srgbClr val="003366"/>
                 </a:solidFill>
@@ -3381,7 +3381,7 @@
           <a:lstStyle/>
           <a:p>
             <a:pPr>
-              <a:defRPr sz="2800" b="1">
+              <a:defRPr sz="3600" b="1">
                 <a:solidFill>
                   <a:srgbClr val="003366"/>
                 </a:solidFill>
@@ -3402,8 +3402,8 @@
         </p:nvSpPr>
         <p:spPr>
           <a:xfrm>
-            <a:off x="731520" y="1097280"/>
-            <a:ext cx="10728655" cy="18288"/>
+            <a:off x="731520" y="1188720"/>
+            <a:ext cx="10728655" cy="27432"/>
           </a:xfrm>
           <a:prstGeom prst="rect">
             <a:avLst/>
@@ -3462,7 +3462,7 @@
           <a:lstStyle/>
           <a:p>
             <a:pPr algn="r">
-              <a:defRPr sz="1000">
+              <a:defRPr sz="1200">
                 <a:solidFill>
                   <a:srgbClr val="808080"/>
                 </a:solidFill>
@@ -3501,6 +3501,174 @@
               <a:spcBef>
                 <a:spcPts val="600"/>
               </a:spcBef>
+              <a:defRPr sz="1700">
+                <a:latin typeface="Calibri"/>
+              </a:defRPr>
+            </a:pPr>
+            <a:r>
+              <a:rPr>
+                <a:solidFill>
+                  <a:srgbClr val="323232"/>
+                </a:solidFill>
+              </a:rPr>
+              <a:t/>
+            </a:r>
+            <a:r>
+              <a:rPr b="1">
+                <a:solidFill>
+                  <a:srgbClr val="003366"/>
+                </a:solidFill>
+              </a:rPr>
+              <a:t>Deployment:</a:t>
+            </a:r>
+            <a:r>
+              <a:rPr>
+                <a:solidFill>
+                  <a:srgbClr val="323232"/>
+                </a:solidFill>
+              </a:rPr>
+              <a:t> Hosted on Hugging Face Spaces for free, public access.</a:t>
+            </a:r>
+          </a:p>
+          <a:p>
+            <a:pPr>
+              <a:spcBef>
+                <a:spcPts val="600"/>
+              </a:spcBef>
+              <a:defRPr sz="1700">
+                <a:latin typeface="Calibri"/>
+              </a:defRPr>
+            </a:pPr>
+            <a:r>
+              <a:rPr>
+                <a:solidFill>
+                  <a:srgbClr val="323232"/>
+                </a:solidFill>
+              </a:rPr>
+              <a:t/>
+            </a:r>
+            <a:r>
+              <a:rPr b="1">
+                <a:solidFill>
+                  <a:srgbClr val="003366"/>
+                </a:solidFill>
+              </a:rPr>
+              <a:t>Web UI:</a:t>
+            </a:r>
+            <a:r>
+              <a:rPr>
+                <a:solidFill>
+                  <a:srgbClr val="323232"/>
+                </a:solidFill>
+              </a:rPr>
+              <a:t> Built using </a:t>
+            </a:r>
+            <a:r>
+              <a:rPr b="1">
+                <a:solidFill>
+                  <a:srgbClr val="003366"/>
+                </a:solidFill>
+              </a:rPr>
+              <a:t>Gradio</a:t>
+            </a:r>
+            <a:r>
+              <a:rPr>
+                <a:solidFill>
+                  <a:srgbClr val="323232"/>
+                </a:solidFill>
+              </a:rPr>
+              <a:t> for a clean, responsive layout.</a:t>
+            </a:r>
+          </a:p>
+          <a:p>
+            <a:pPr>
+              <a:spcBef>
+                <a:spcPts val="600"/>
+              </a:spcBef>
+              <a:defRPr sz="1700">
+                <a:latin typeface="Calibri"/>
+              </a:defRPr>
+            </a:pPr>
+            <a:r>
+              <a:rPr>
+                <a:solidFill>
+                  <a:srgbClr val="323232"/>
+                </a:solidFill>
+              </a:rPr>
+              <a:t/>
+            </a:r>
+            <a:r>
+              <a:rPr b="1">
+                <a:solidFill>
+                  <a:srgbClr val="003366"/>
+                </a:solidFill>
+              </a:rPr>
+              <a:t>Inference Engine:</a:t>
+            </a:r>
+            <a:r>
+              <a:rPr>
+                <a:solidFill>
+                  <a:srgbClr val="323232"/>
+                </a:solidFill>
+              </a:rPr>
+              <a:t> Powered by </a:t>
+            </a:r>
+            <a:r>
+              <a:rPr b="1">
+                <a:solidFill>
+                  <a:srgbClr val="003366"/>
+                </a:solidFill>
+              </a:rPr>
+              <a:t>ONNX Runtime (ort)</a:t>
+            </a:r>
+            <a:r>
+              <a:rPr>
+                <a:solidFill>
+                  <a:srgbClr val="323232"/>
+                </a:solidFill>
+              </a:rPr>
+              <a:t>, running on CPU with millisecond response time.</a:t>
+            </a:r>
+          </a:p>
+          <a:p>
+            <a:pPr>
+              <a:spcBef>
+                <a:spcPts val="600"/>
+              </a:spcBef>
+              <a:defRPr sz="1700">
+                <a:latin typeface="Calibri"/>
+              </a:defRPr>
+            </a:pPr>
+            <a:r>
+              <a:rPr>
+                <a:solidFill>
+                  <a:srgbClr val="323232"/>
+                </a:solidFill>
+              </a:rPr>
+              <a:t/>
+            </a:r>
+            <a:r>
+              <a:rPr b="1">
+                <a:solidFill>
+                  <a:srgbClr val="003366"/>
+                </a:solidFill>
+              </a:rPr>
+              <a:t>User Workflow:</a:t>
+            </a:r>
+            <a:r>
+              <a:rPr>
+                <a:solidFill>
+                  <a:srgbClr val="323232"/>
+                </a:solidFill>
+              </a:rPr>
+              <a:t/>
+            </a:r>
+          </a:p>
+          <a:p>
+            <a:pPr>
+              <a:spcBef>
+                <a:spcPts val="600"/>
+              </a:spcBef>
               <a:defRPr sz="1400">
                 <a:latin typeface="Calibri"/>
               </a:defRPr>
@@ -3508,26 +3676,10 @@
             <a:r>
               <a:rPr>
                 <a:solidFill>
-                  <a:srgbClr val="3C3C3C"/>
-                </a:solidFill>
-              </a:rPr>
-              <a:t/>
-            </a:r>
-            <a:r>
-              <a:rPr b="1">
-                <a:solidFill>
-                  <a:srgbClr val="003366"/>
-                </a:solidFill>
-              </a:rPr>
-              <a:t>Deployment:</a:t>
-            </a:r>
-            <a:r>
-              <a:rPr>
-                <a:solidFill>
-                  <a:srgbClr val="3C3C3C"/>
-                </a:solidFill>
-              </a:rPr>
-              <a:t> Hosted on Hugging Face Spaces for free, public access.</a:t>
+                  <a:srgbClr val="323232"/>
+                </a:solidFill>
+              </a:rPr>
+              <a:t>  1. Upload a brain MRI scan (.jpg/.png).</a:t>
             </a:r>
           </a:p>
           <a:p>
@@ -3542,42 +3694,10 @@
             <a:r>
               <a:rPr>
                 <a:solidFill>
-                  <a:srgbClr val="3C3C3C"/>
-                </a:solidFill>
-              </a:rPr>
-              <a:t/>
-            </a:r>
-            <a:r>
-              <a:rPr b="1">
-                <a:solidFill>
-                  <a:srgbClr val="003366"/>
-                </a:solidFill>
-              </a:rPr>
-              <a:t>Web UI:</a:t>
-            </a:r>
-            <a:r>
-              <a:rPr>
-                <a:solidFill>
-                  <a:srgbClr val="3C3C3C"/>
-                </a:solidFill>
-              </a:rPr>
-              <a:t> Built using </a:t>
-            </a:r>
-            <a:r>
-              <a:rPr b="1">
-                <a:solidFill>
-                  <a:srgbClr val="003366"/>
-                </a:solidFill>
-              </a:rPr>
-              <a:t>Gradio</a:t>
-            </a:r>
-            <a:r>
-              <a:rPr>
-                <a:solidFill>
-                  <a:srgbClr val="3C3C3C"/>
-                </a:solidFill>
-              </a:rPr>
-              <a:t> for a clean, responsive layout.</a:t>
+                  <a:srgbClr val="323232"/>
+                </a:solidFill>
+              </a:rPr>
+              <a:t>  2. Click the 'Analyze MRI' button.</a:t>
             </a:r>
           </a:p>
           <a:p>
@@ -3592,42 +3712,10 @@
             <a:r>
               <a:rPr>
                 <a:solidFill>
-                  <a:srgbClr val="3C3C3C"/>
-                </a:solidFill>
-              </a:rPr>
-              <a:t/>
-            </a:r>
-            <a:r>
-              <a:rPr b="1">
-                <a:solidFill>
-                  <a:srgbClr val="003366"/>
-                </a:solidFill>
-              </a:rPr>
-              <a:t>Inference Engine:</a:t>
-            </a:r>
-            <a:r>
-              <a:rPr>
-                <a:solidFill>
-                  <a:srgbClr val="3C3C3C"/>
-                </a:solidFill>
-              </a:rPr>
-              <a:t> Powered by </a:t>
-            </a:r>
-            <a:r>
-              <a:rPr b="1">
-                <a:solidFill>
-                  <a:srgbClr val="003366"/>
-                </a:solidFill>
-              </a:rPr>
-              <a:t>ONNX Runtime (ort)</a:t>
-            </a:r>
-            <a:r>
-              <a:rPr>
-                <a:solidFill>
-                  <a:srgbClr val="3C3C3C"/>
-                </a:solidFill>
-              </a:rPr>
-              <a:t>, running on CPU with millisecond response time.</a:t>
+                  <a:srgbClr val="323232"/>
+                </a:solidFill>
+              </a:rPr>
+              <a:t>  3. View the predicted tumor category with a confidence score breakdown across all four classes.</a:t>
             </a:r>
           </a:p>
           <a:p>
@@ -3642,95 +3730,7 @@
             <a:r>
               <a:rPr>
                 <a:solidFill>
-                  <a:srgbClr val="3C3C3C"/>
-                </a:solidFill>
-              </a:rPr>
-              <a:t/>
-            </a:r>
-            <a:r>
-              <a:rPr b="1">
-                <a:solidFill>
-                  <a:srgbClr val="003366"/>
-                </a:solidFill>
-              </a:rPr>
-              <a:t>User Workflow:</a:t>
-            </a:r>
-            <a:r>
-              <a:rPr>
-                <a:solidFill>
-                  <a:srgbClr val="3C3C3C"/>
-                </a:solidFill>
-              </a:rPr>
-              <a:t/>
-            </a:r>
-          </a:p>
-          <a:p>
-            <a:pPr>
-              <a:spcBef>
-                <a:spcPts val="600"/>
-              </a:spcBef>
-              <a:defRPr sz="1200">
-                <a:latin typeface="Calibri"/>
-              </a:defRPr>
-            </a:pPr>
-            <a:r>
-              <a:rPr>
-                <a:solidFill>
-                  <a:srgbClr val="3C3C3C"/>
-                </a:solidFill>
-              </a:rPr>
-              <a:t>  1. Upload a brain MRI scan (.jpg/.png).</a:t>
-            </a:r>
-          </a:p>
-          <a:p>
-            <a:pPr>
-              <a:spcBef>
-                <a:spcPts val="600"/>
-              </a:spcBef>
-              <a:defRPr sz="1200">
-                <a:latin typeface="Calibri"/>
-              </a:defRPr>
-            </a:pPr>
-            <a:r>
-              <a:rPr>
-                <a:solidFill>
-                  <a:srgbClr val="3C3C3C"/>
-                </a:solidFill>
-              </a:rPr>
-              <a:t>  2. Click the 'Analyze MRI' button.</a:t>
-            </a:r>
-          </a:p>
-          <a:p>
-            <a:pPr>
-              <a:spcBef>
-                <a:spcPts val="600"/>
-              </a:spcBef>
-              <a:defRPr sz="1200">
-                <a:latin typeface="Calibri"/>
-              </a:defRPr>
-            </a:pPr>
-            <a:r>
-              <a:rPr>
-                <a:solidFill>
-                  <a:srgbClr val="3C3C3C"/>
-                </a:solidFill>
-              </a:rPr>
-              <a:t>  3. View the predicted tumor category with a confidence score breakdown across all four classes.</a:t>
-            </a:r>
-          </a:p>
-          <a:p>
-            <a:pPr>
-              <a:spcBef>
-                <a:spcPts val="600"/>
-              </a:spcBef>
-              <a:defRPr sz="1200">
-                <a:latin typeface="Calibri"/>
-              </a:defRPr>
-            </a:pPr>
-            <a:r>
-              <a:rPr>
-                <a:solidFill>
-                  <a:srgbClr val="3C3C3C"/>
+                  <a:srgbClr val="323232"/>
                 </a:solidFill>
               </a:rPr>
               <a:t>  4. Read a short clinical description of the predicted class.</a:t>
@@ -3761,7 +3761,7 @@
           <a:lstStyle/>
           <a:p>
             <a:pPr algn="ctr">
-              <a:defRPr sz="1300" b="1">
+              <a:defRPr sz="1600" b="1">
                 <a:solidFill>
                   <a:srgbClr val="003366"/>
                 </a:solidFill>
@@ -3790,8 +3790,8 @@
         </p:blipFill>
         <p:spPr>
           <a:xfrm>
-            <a:off x="5943600" y="1554480"/>
-            <a:ext cx="5486400" cy="3931920"/>
+            <a:off x="5943600" y="1645920"/>
+            <a:ext cx="5486400" cy="4114800"/>
           </a:xfrm>
           <a:prstGeom prst="rect">
             <a:avLst/>
@@ -3839,7 +3839,7 @@
           <a:lstStyle/>
           <a:p>
             <a:pPr>
-              <a:defRPr sz="2800" b="1">
+              <a:defRPr sz="3600" b="1">
                 <a:solidFill>
                   <a:srgbClr val="003366"/>
                 </a:solidFill>
@@ -3860,8 +3860,8 @@
         </p:nvSpPr>
         <p:spPr>
           <a:xfrm>
-            <a:off x="731520" y="1097280"/>
-            <a:ext cx="10728655" cy="18288"/>
+            <a:off x="731520" y="1188720"/>
+            <a:ext cx="10728655" cy="27432"/>
           </a:xfrm>
           <a:prstGeom prst="rect">
             <a:avLst/>
@@ -3920,7 +3920,7 @@
           <a:lstStyle/>
           <a:p>
             <a:pPr algn="r">
-              <a:defRPr sz="1000">
+              <a:defRPr sz="1200">
                 <a:solidFill>
                   <a:srgbClr val="808080"/>
                 </a:solidFill>
@@ -3959,14 +3959,14 @@
               <a:spcBef>
                 <a:spcPts val="800"/>
               </a:spcBef>
-              <a:defRPr sz="1400">
-                <a:latin typeface="Calibri"/>
-              </a:defRPr>
-            </a:pPr>
-            <a:r>
-              <a:rPr>
-                <a:solidFill>
-                  <a:srgbClr val="3C3C3C"/>
+              <a:defRPr sz="1700">
+                <a:latin typeface="Calibri"/>
+              </a:defRPr>
+            </a:pPr>
+            <a:r>
+              <a:rPr>
+                <a:solidFill>
+                  <a:srgbClr val="323232"/>
                 </a:solidFill>
               </a:rPr>
               <a:t/>
@@ -3982,7 +3982,7 @@
             <a:r>
               <a:rPr>
                 <a:solidFill>
-                  <a:srgbClr val="3C3C3C"/>
+                  <a:srgbClr val="323232"/>
                 </a:solidFill>
               </a:rPr>
               <a:t> Gradient-weighted Class Activation Mapping computes heatmaps showing which regions of the MRI the model focused on for its prediction.</a:t>
@@ -3993,14 +3993,14 @@
               <a:spcBef>
                 <a:spcPts val="800"/>
               </a:spcBef>
-              <a:defRPr sz="1400">
-                <a:latin typeface="Calibri"/>
-              </a:defRPr>
-            </a:pPr>
-            <a:r>
-              <a:rPr>
-                <a:solidFill>
-                  <a:srgbClr val="3C3C3C"/>
+              <a:defRPr sz="1700">
+                <a:latin typeface="Calibri"/>
+              </a:defRPr>
+            </a:pPr>
+            <a:r>
+              <a:rPr>
+                <a:solidFill>
+                  <a:srgbClr val="323232"/>
                 </a:solidFill>
               </a:rPr>
               <a:t/>
@@ -4016,7 +4016,7 @@
             <a:r>
               <a:rPr>
                 <a:solidFill>
-                  <a:srgbClr val="3C3C3C"/>
+                  <a:srgbClr val="323232"/>
                 </a:solidFill>
               </a:rPr>
               <a:t> Implemented and validated during model development in the training notebook, using the final convolutional layer (`top_conv`) of the EfficientNetB0 backbone.</a:t>
@@ -4027,14 +4027,14 @@
               <a:spcBef>
                 <a:spcPts val="800"/>
               </a:spcBef>
-              <a:defRPr sz="1400">
-                <a:latin typeface="Calibri"/>
-              </a:defRPr>
-            </a:pPr>
-            <a:r>
-              <a:rPr>
-                <a:solidFill>
-                  <a:srgbClr val="3C3C3C"/>
+              <a:defRPr sz="1700">
+                <a:latin typeface="Calibri"/>
+              </a:defRPr>
+            </a:pPr>
+            <a:r>
+              <a:rPr>
+                <a:solidFill>
+                  <a:srgbClr val="323232"/>
                 </a:solidFill>
               </a:rPr>
               <a:t/>
@@ -4050,7 +4050,7 @@
             <a:r>
               <a:rPr>
                 <a:solidFill>
-                  <a:srgbClr val="3C3C3C"/>
+                  <a:srgbClr val="323232"/>
                 </a:solidFill>
               </a:rPr>
               <a:t> Lets a radiologist visually confirm the model is attending to the actual tumor region rather than irrelevant background, building trust before deployment.</a:t>
@@ -4061,14 +4061,14 @@
               <a:spcBef>
                 <a:spcPts val="800"/>
               </a:spcBef>
-              <a:defRPr sz="1400">
-                <a:latin typeface="Calibri"/>
-              </a:defRPr>
-            </a:pPr>
-            <a:r>
-              <a:rPr>
-                <a:solidFill>
-                  <a:srgbClr val="3C3C3C"/>
+              <a:defRPr sz="1700">
+                <a:latin typeface="Calibri"/>
+              </a:defRPr>
+            </a:pPr>
+            <a:r>
+              <a:rPr>
+                <a:solidFill>
+                  <a:srgbClr val="323232"/>
                 </a:solidFill>
               </a:rPr>
               <a:t/>
@@ -4084,7 +4084,7 @@
             <a:r>
               <a:rPr>
                 <a:solidFill>
-                  <a:srgbClr val="3C3C3C"/>
+                  <a:srgbClr val="323232"/>
                 </a:solidFill>
               </a:rPr>
               <a:t> This visualization currently runs in the training/analysis notebook; integrating it directly into the live web app is planned as future work.</a:t>
@@ -4115,7 +4115,7 @@
           <a:lstStyle/>
           <a:p>
             <a:pPr algn="ctr">
-              <a:defRPr sz="1300" b="1">
+              <a:defRPr sz="1600" b="1">
                 <a:solidFill>
                   <a:srgbClr val="003366"/>
                 </a:solidFill>
@@ -4144,8 +4144,8 @@
         </p:blipFill>
         <p:spPr>
           <a:xfrm>
-            <a:off x="6217920" y="1554480"/>
-            <a:ext cx="5212080" cy="4389120"/>
+            <a:off x="6217920" y="1645920"/>
+            <a:ext cx="5212080" cy="4297680"/>
           </a:xfrm>
           <a:prstGeom prst="rect">
             <a:avLst/>
@@ -4193,7 +4193,7 @@
           <a:lstStyle/>
           <a:p>
             <a:pPr>
-              <a:defRPr sz="2800" b="1">
+              <a:defRPr sz="3600" b="1">
                 <a:solidFill>
                   <a:srgbClr val="003366"/>
                 </a:solidFill>
@@ -4214,8 +4214,8 @@
         </p:nvSpPr>
         <p:spPr>
           <a:xfrm>
-            <a:off x="731520" y="1097280"/>
-            <a:ext cx="10728655" cy="18288"/>
+            <a:off x="731520" y="1188720"/>
+            <a:ext cx="10728655" cy="27432"/>
           </a:xfrm>
           <a:prstGeom prst="rect">
             <a:avLst/>
@@ -4274,7 +4274,7 @@
           <a:lstStyle/>
           <a:p>
             <a:pPr algn="r">
-              <a:defRPr sz="1000">
+              <a:defRPr sz="1200">
                 <a:solidFill>
                   <a:srgbClr val="808080"/>
                 </a:solidFill>
@@ -4313,6 +4313,208 @@
               <a:spcBef>
                 <a:spcPts val="800"/>
               </a:spcBef>
+              <a:defRPr sz="1800">
+                <a:latin typeface="Calibri"/>
+              </a:defRPr>
+            </a:pPr>
+            <a:r>
+              <a:rPr>
+                <a:solidFill>
+                  <a:srgbClr val="323232"/>
+                </a:solidFill>
+              </a:rPr>
+              <a:t/>
+            </a:r>
+            <a:r>
+              <a:rPr b="1">
+                <a:solidFill>
+                  <a:srgbClr val="003366"/>
+                </a:solidFill>
+              </a:rPr>
+              <a:t>End-to-End Pipeline:</a:t>
+            </a:r>
+            <a:r>
+              <a:rPr>
+                <a:solidFill>
+                  <a:srgbClr val="323232"/>
+                </a:solidFill>
+              </a:rPr>
+              <a:t> Successfully built and delivered a complete pipeline from automated dataset download to deployed web application.</a:t>
+            </a:r>
+          </a:p>
+          <a:p>
+            <a:pPr>
+              <a:spcBef>
+                <a:spcPts val="800"/>
+              </a:spcBef>
+              <a:defRPr sz="1800">
+                <a:latin typeface="Calibri"/>
+              </a:defRPr>
+            </a:pPr>
+            <a:r>
+              <a:rPr>
+                <a:solidFill>
+                  <a:srgbClr val="323232"/>
+                </a:solidFill>
+              </a:rPr>
+              <a:t/>
+            </a:r>
+            <a:r>
+              <a:rPr b="1">
+                <a:solidFill>
+                  <a:srgbClr val="003366"/>
+                </a:solidFill>
+              </a:rPr>
+              <a:t>Methodological Success:</a:t>
+            </a:r>
+            <a:r>
+              <a:rPr>
+                <a:solidFill>
+                  <a:srgbClr val="323232"/>
+                </a:solidFill>
+              </a:rPr>
+              <a:t> EfficientNetB0 transfer learning achieved </a:t>
+            </a:r>
+            <a:r>
+              <a:rPr b="1">
+                <a:solidFill>
+                  <a:srgbClr val="003366"/>
+                </a:solidFill>
+              </a:rPr>
+              <a:t>99.59%</a:t>
+            </a:r>
+            <a:r>
+              <a:rPr>
+                <a:solidFill>
+                  <a:srgbClr val="323232"/>
+                </a:solidFill>
+              </a:rPr>
+              <a:t> accuracy on tumor cases and </a:t>
+            </a:r>
+            <a:r>
+              <a:rPr b="1">
+                <a:solidFill>
+                  <a:srgbClr val="003366"/>
+                </a:solidFill>
+              </a:rPr>
+              <a:t>99.99%</a:t>
+            </a:r>
+            <a:r>
+              <a:rPr>
+                <a:solidFill>
+                  <a:srgbClr val="323232"/>
+                </a:solidFill>
+              </a:rPr>
+              <a:t> on healthy cases after resolving a critical preprocessing bug.</a:t>
+            </a:r>
+          </a:p>
+          <a:p>
+            <a:pPr>
+              <a:spcBef>
+                <a:spcPts val="800"/>
+              </a:spcBef>
+              <a:defRPr sz="1800">
+                <a:latin typeface="Calibri"/>
+              </a:defRPr>
+            </a:pPr>
+            <a:r>
+              <a:rPr>
+                <a:solidFill>
+                  <a:srgbClr val="323232"/>
+                </a:solidFill>
+              </a:rPr>
+              <a:t/>
+            </a:r>
+            <a:r>
+              <a:rPr b="1">
+                <a:solidFill>
+                  <a:srgbClr val="003366"/>
+                </a:solidFill>
+              </a:rPr>
+              <a:t>Validated Explainability:</a:t>
+            </a:r>
+            <a:r>
+              <a:rPr>
+                <a:solidFill>
+                  <a:srgbClr val="323232"/>
+                </a:solidFill>
+              </a:rPr>
+              <a:t> Grad-CAM explainability was developed and validated in the training notebook to support model trust.</a:t>
+            </a:r>
+          </a:p>
+          <a:p>
+            <a:pPr>
+              <a:spcBef>
+                <a:spcPts val="800"/>
+              </a:spcBef>
+              <a:defRPr sz="1800">
+                <a:latin typeface="Calibri"/>
+              </a:defRPr>
+            </a:pPr>
+            <a:r>
+              <a:rPr>
+                <a:solidFill>
+                  <a:srgbClr val="323232"/>
+                </a:solidFill>
+              </a:rPr>
+              <a:t/>
+            </a:r>
+            <a:r>
+              <a:rPr b="1">
+                <a:solidFill>
+                  <a:srgbClr val="003366"/>
+                </a:solidFill>
+              </a:rPr>
+              <a:t>Lightweight Deployment:</a:t>
+            </a:r>
+            <a:r>
+              <a:rPr>
+                <a:solidFill>
+                  <a:srgbClr val="323232"/>
+                </a:solidFill>
+              </a:rPr>
+              <a:t> Deployed a lightweight, CPU-run Gradio app on Hugging Face Spaces using ONNX Runtime.</a:t>
+            </a:r>
+          </a:p>
+          <a:p>
+            <a:pPr>
+              <a:spcBef>
+                <a:spcPts val="800"/>
+              </a:spcBef>
+              <a:defRPr sz="1800">
+                <a:latin typeface="Calibri"/>
+              </a:defRPr>
+            </a:pPr>
+            <a:r>
+              <a:rPr>
+                <a:solidFill>
+                  <a:srgbClr val="323232"/>
+                </a:solidFill>
+              </a:rPr>
+              <a:t/>
+            </a:r>
+            <a:r>
+              <a:rPr b="1">
+                <a:solidFill>
+                  <a:srgbClr val="003366"/>
+                </a:solidFill>
+              </a:rPr>
+              <a:t>Future Work:</a:t>
+            </a:r>
+            <a:r>
+              <a:rPr>
+                <a:solidFill>
+                  <a:srgbClr val="323232"/>
+                </a:solidFill>
+              </a:rPr>
+              <a:t/>
+            </a:r>
+          </a:p>
+          <a:p>
+            <a:pPr>
+              <a:spcBef>
+                <a:spcPts val="800"/>
+              </a:spcBef>
               <a:defRPr sz="1500">
                 <a:latin typeface="Calibri"/>
               </a:defRPr>
@@ -4320,26 +4522,10 @@
             <a:r>
               <a:rPr>
                 <a:solidFill>
-                  <a:srgbClr val="3C3C3C"/>
-                </a:solidFill>
-              </a:rPr>
-              <a:t/>
-            </a:r>
-            <a:r>
-              <a:rPr b="1">
-                <a:solidFill>
-                  <a:srgbClr val="003366"/>
-                </a:solidFill>
-              </a:rPr>
-              <a:t>End-to-End Pipeline:</a:t>
-            </a:r>
-            <a:r>
-              <a:rPr>
-                <a:solidFill>
-                  <a:srgbClr val="3C3C3C"/>
-                </a:solidFill>
-              </a:rPr>
-              <a:t> Successfully built and delivered a complete pipeline from automated dataset download to deployed web application.</a:t>
+                  <a:srgbClr val="323232"/>
+                </a:solidFill>
+              </a:rPr>
+              <a:t>  - Integrate live Grad-CAM heatmap visualization directly into the deployed web application.</a:t>
             </a:r>
           </a:p>
           <a:p>
@@ -4354,58 +4540,10 @@
             <a:r>
               <a:rPr>
                 <a:solidFill>
-                  <a:srgbClr val="3C3C3C"/>
-                </a:solidFill>
-              </a:rPr>
-              <a:t/>
-            </a:r>
-            <a:r>
-              <a:rPr b="1">
-                <a:solidFill>
-                  <a:srgbClr val="003366"/>
-                </a:solidFill>
-              </a:rPr>
-              <a:t>Methodological Success:</a:t>
-            </a:r>
-            <a:r>
-              <a:rPr>
-                <a:solidFill>
-                  <a:srgbClr val="3C3C3C"/>
-                </a:solidFill>
-              </a:rPr>
-              <a:t> EfficientNetB0 transfer learning achieved </a:t>
-            </a:r>
-            <a:r>
-              <a:rPr b="1">
-                <a:solidFill>
-                  <a:srgbClr val="003366"/>
-                </a:solidFill>
-              </a:rPr>
-              <a:t>99.59%</a:t>
-            </a:r>
-            <a:r>
-              <a:rPr>
-                <a:solidFill>
-                  <a:srgbClr val="3C3C3C"/>
-                </a:solidFill>
-              </a:rPr>
-              <a:t> accuracy on tumor cases and </a:t>
-            </a:r>
-            <a:r>
-              <a:rPr b="1">
-                <a:solidFill>
-                  <a:srgbClr val="003366"/>
-                </a:solidFill>
-              </a:rPr>
-              <a:t>99.99%</a:t>
-            </a:r>
-            <a:r>
-              <a:rPr>
-                <a:solidFill>
-                  <a:srgbClr val="3C3C3C"/>
-                </a:solidFill>
-              </a:rPr>
-              <a:t> on healthy cases after resolving a critical preprocessing bug.</a:t>
+                  <a:srgbClr val="323232"/>
+                </a:solidFill>
+              </a:rPr>
+              <a:t>  - Expand the classification model to more brain tumor subtypes.</a:t>
             </a:r>
           </a:p>
           <a:p>
@@ -4420,145 +4558,7 @@
             <a:r>
               <a:rPr>
                 <a:solidFill>
-                  <a:srgbClr val="3C3C3C"/>
-                </a:solidFill>
-              </a:rPr>
-              <a:t/>
-            </a:r>
-            <a:r>
-              <a:rPr b="1">
-                <a:solidFill>
-                  <a:srgbClr val="003366"/>
-                </a:solidFill>
-              </a:rPr>
-              <a:t>Validated Explainability:</a:t>
-            </a:r>
-            <a:r>
-              <a:rPr>
-                <a:solidFill>
-                  <a:srgbClr val="3C3C3C"/>
-                </a:solidFill>
-              </a:rPr>
-              <a:t> Grad-CAM explainability was developed and validated in the training notebook to support model trust.</a:t>
-            </a:r>
-          </a:p>
-          <a:p>
-            <a:pPr>
-              <a:spcBef>
-                <a:spcPts val="800"/>
-              </a:spcBef>
-              <a:defRPr sz="1500">
-                <a:latin typeface="Calibri"/>
-              </a:defRPr>
-            </a:pPr>
-            <a:r>
-              <a:rPr>
-                <a:solidFill>
-                  <a:srgbClr val="3C3C3C"/>
-                </a:solidFill>
-              </a:rPr>
-              <a:t/>
-            </a:r>
-            <a:r>
-              <a:rPr b="1">
-                <a:solidFill>
-                  <a:srgbClr val="003366"/>
-                </a:solidFill>
-              </a:rPr>
-              <a:t>Lightweight Deployment:</a:t>
-            </a:r>
-            <a:r>
-              <a:rPr>
-                <a:solidFill>
-                  <a:srgbClr val="3C3C3C"/>
-                </a:solidFill>
-              </a:rPr>
-              <a:t> Deployed a lightweight, CPU-run Gradio app on Hugging Face Spaces using ONNX Runtime.</a:t>
-            </a:r>
-          </a:p>
-          <a:p>
-            <a:pPr>
-              <a:spcBef>
-                <a:spcPts val="800"/>
-              </a:spcBef>
-              <a:defRPr sz="1500">
-                <a:latin typeface="Calibri"/>
-              </a:defRPr>
-            </a:pPr>
-            <a:r>
-              <a:rPr>
-                <a:solidFill>
-                  <a:srgbClr val="3C3C3C"/>
-                </a:solidFill>
-              </a:rPr>
-              <a:t/>
-            </a:r>
-            <a:r>
-              <a:rPr b="1">
-                <a:solidFill>
-                  <a:srgbClr val="003366"/>
-                </a:solidFill>
-              </a:rPr>
-              <a:t>Future Work:</a:t>
-            </a:r>
-            <a:r>
-              <a:rPr>
-                <a:solidFill>
-                  <a:srgbClr val="3C3C3C"/>
-                </a:solidFill>
-              </a:rPr>
-              <a:t/>
-            </a:r>
-          </a:p>
-          <a:p>
-            <a:pPr>
-              <a:spcBef>
-                <a:spcPts val="800"/>
-              </a:spcBef>
-              <a:defRPr sz="1300">
-                <a:latin typeface="Calibri"/>
-              </a:defRPr>
-            </a:pPr>
-            <a:r>
-              <a:rPr>
-                <a:solidFill>
-                  <a:srgbClr val="3C3C3C"/>
-                </a:solidFill>
-              </a:rPr>
-              <a:t>  - Integrate live Grad-CAM heatmap visualization directly into the deployed web application.</a:t>
-            </a:r>
-          </a:p>
-          <a:p>
-            <a:pPr>
-              <a:spcBef>
-                <a:spcPts val="800"/>
-              </a:spcBef>
-              <a:defRPr sz="1300">
-                <a:latin typeface="Calibri"/>
-              </a:defRPr>
-            </a:pPr>
-            <a:r>
-              <a:rPr>
-                <a:solidFill>
-                  <a:srgbClr val="3C3C3C"/>
-                </a:solidFill>
-              </a:rPr>
-              <a:t>  - Expand the classification model to more brain tumor subtypes.</a:t>
-            </a:r>
-          </a:p>
-          <a:p>
-            <a:pPr>
-              <a:spcBef>
-                <a:spcPts val="800"/>
-              </a:spcBef>
-              <a:defRPr sz="1300">
-                <a:latin typeface="Calibri"/>
-              </a:defRPr>
-            </a:pPr>
-            <a:r>
-              <a:rPr>
-                <a:solidFill>
-                  <a:srgbClr val="3C3C3C"/>
+                  <a:srgbClr val="323232"/>
                 </a:solidFill>
               </a:rPr>
               <a:t>  - Add U-Net segmentation models for tumor volume quantification.</a:t>
@@ -4650,7 +4650,7 @@
           <a:lstStyle/>
           <a:p>
             <a:pPr algn="ctr">
-              <a:defRPr sz="6400" b="1">
+              <a:defRPr sz="7200" b="1">
                 <a:solidFill>
                   <a:srgbClr val="FFFFFF"/>
                 </a:solidFill>
@@ -4666,7 +4666,7 @@
               <a:spcBef>
                 <a:spcPts val="4000"/>
               </a:spcBef>
-              <a:defRPr sz="1500">
+              <a:defRPr sz="2000">
                 <a:solidFill>
                   <a:srgbClr val="E6F0FF"/>
                 </a:solidFill>
@@ -4724,7 +4724,7 @@
           <a:lstStyle/>
           <a:p>
             <a:pPr>
-              <a:defRPr sz="2800" b="1">
+              <a:defRPr sz="3600" b="1">
                 <a:solidFill>
                   <a:srgbClr val="003366"/>
                 </a:solidFill>
@@ -4745,8 +4745,8 @@
         </p:nvSpPr>
         <p:spPr>
           <a:xfrm>
-            <a:off x="731520" y="1097280"/>
-            <a:ext cx="10728655" cy="18288"/>
+            <a:off x="731520" y="1188720"/>
+            <a:ext cx="10728655" cy="27432"/>
           </a:xfrm>
           <a:prstGeom prst="rect">
             <a:avLst/>
@@ -4805,7 +4805,7 @@
           <a:lstStyle/>
           <a:p>
             <a:pPr algn="r">
-              <a:defRPr sz="1000">
+              <a:defRPr sz="1200">
                 <a:solidFill>
                   <a:srgbClr val="808080"/>
                 </a:solidFill>
@@ -4844,14 +4844,14 @@
               <a:spcBef>
                 <a:spcPts val="800"/>
               </a:spcBef>
-              <a:defRPr sz="1500">
-                <a:latin typeface="Calibri"/>
-              </a:defRPr>
-            </a:pPr>
-            <a:r>
-              <a:rPr>
-                <a:solidFill>
-                  <a:srgbClr val="3C3C3C"/>
+              <a:defRPr sz="1800">
+                <a:latin typeface="Calibri"/>
+              </a:defRPr>
+            </a:pPr>
+            <a:r>
+              <a:rPr>
+                <a:solidFill>
+                  <a:srgbClr val="323232"/>
                 </a:solidFill>
               </a:rPr>
               <a:t/>
@@ -4867,7 +4867,7 @@
             <a:r>
               <a:rPr>
                 <a:solidFill>
-                  <a:srgbClr val="3C3C3C"/>
+                  <a:srgbClr val="323232"/>
                 </a:solidFill>
               </a:rPr>
               <a:t> Detect and classify brain MRI scans into four classes: Glioma, Meningioma, Pituitary, and No Tumor.</a:t>
@@ -4878,14 +4878,14 @@
               <a:spcBef>
                 <a:spcPts val="800"/>
               </a:spcBef>
-              <a:defRPr sz="1500">
-                <a:latin typeface="Calibri"/>
-              </a:defRPr>
-            </a:pPr>
-            <a:r>
-              <a:rPr>
-                <a:solidFill>
-                  <a:srgbClr val="3C3C3C"/>
+              <a:defRPr sz="1800">
+                <a:latin typeface="Calibri"/>
+              </a:defRPr>
+            </a:pPr>
+            <a:r>
+              <a:rPr>
+                <a:solidFill>
+                  <a:srgbClr val="323232"/>
                 </a:solidFill>
               </a:rPr>
               <a:t/>
@@ -4901,7 +4901,7 @@
             <a:r>
               <a:rPr>
                 <a:solidFill>
-                  <a:srgbClr val="3C3C3C"/>
+                  <a:srgbClr val="323232"/>
                 </a:solidFill>
               </a:rPr>
               <a:t> Uses the Brain Tumor MRI Dataset from Kaggle containing a total of 7,023 images.</a:t>
@@ -4912,14 +4912,14 @@
               <a:spcBef>
                 <a:spcPts val="800"/>
               </a:spcBef>
-              <a:defRPr sz="1500">
-                <a:latin typeface="Calibri"/>
-              </a:defRPr>
-            </a:pPr>
-            <a:r>
-              <a:rPr>
-                <a:solidFill>
-                  <a:srgbClr val="3C3C3C"/>
+              <a:defRPr sz="1800">
+                <a:latin typeface="Calibri"/>
+              </a:defRPr>
+            </a:pPr>
+            <a:r>
+              <a:rPr>
+                <a:solidFill>
+                  <a:srgbClr val="323232"/>
                 </a:solidFill>
               </a:rPr>
               <a:t/>
@@ -4935,7 +4935,7 @@
             <a:r>
               <a:rPr>
                 <a:solidFill>
-                  <a:srgbClr val="3C3C3C"/>
+                  <a:srgbClr val="323232"/>
                 </a:solidFill>
               </a:rPr>
               <a:t> Applies transfer learning using the EfficientNetB0 architecture pretrained on ImageNet database.</a:t>
@@ -4946,14 +4946,14 @@
               <a:spcBef>
                 <a:spcPts val="800"/>
               </a:spcBef>
-              <a:defRPr sz="1500">
-                <a:latin typeface="Calibri"/>
-              </a:defRPr>
-            </a:pPr>
-            <a:r>
-              <a:rPr>
-                <a:solidFill>
-                  <a:srgbClr val="3C3C3C"/>
+              <a:defRPr sz="1800">
+                <a:latin typeface="Calibri"/>
+              </a:defRPr>
+            </a:pPr>
+            <a:r>
+              <a:rPr>
+                <a:solidFill>
+                  <a:srgbClr val="323232"/>
                 </a:solidFill>
               </a:rPr>
               <a:t/>
@@ -4969,7 +4969,7 @@
             <a:r>
               <a:rPr>
                 <a:solidFill>
-                  <a:srgbClr val="3C3C3C"/>
+                  <a:srgbClr val="323232"/>
                 </a:solidFill>
               </a:rPr>
               <a:t> Incorporates online data augmentation, validation splits, and a structured two-phase training strategy.</a:t>
@@ -4980,14 +4980,14 @@
               <a:spcBef>
                 <a:spcPts val="800"/>
               </a:spcBef>
-              <a:defRPr sz="1500">
-                <a:latin typeface="Calibri"/>
-              </a:defRPr>
-            </a:pPr>
-            <a:r>
-              <a:rPr>
-                <a:solidFill>
-                  <a:srgbClr val="3C3C3C"/>
+              <a:defRPr sz="1800">
+                <a:latin typeface="Calibri"/>
+              </a:defRPr>
+            </a:pPr>
+            <a:r>
+              <a:rPr>
+                <a:solidFill>
+                  <a:srgbClr val="323232"/>
                 </a:solidFill>
               </a:rPr>
               <a:t/>
@@ -5003,7 +5003,7 @@
             <a:r>
               <a:rPr>
                 <a:solidFill>
-                  <a:srgbClr val="3C3C3C"/>
+                  <a:srgbClr val="323232"/>
                 </a:solidFill>
               </a:rPr>
               <a:t> Computes Grad-CAM heatmap visualizations to explain model predictions clinically.</a:t>
@@ -5014,14 +5014,14 @@
               <a:spcBef>
                 <a:spcPts val="800"/>
               </a:spcBef>
-              <a:defRPr sz="1500">
-                <a:latin typeface="Calibri"/>
-              </a:defRPr>
-            </a:pPr>
-            <a:r>
-              <a:rPr>
-                <a:solidFill>
-                  <a:srgbClr val="3C3C3C"/>
+              <a:defRPr sz="1800">
+                <a:latin typeface="Calibri"/>
+              </a:defRPr>
+            </a:pPr>
+            <a:r>
+              <a:rPr>
+                <a:solidFill>
+                  <a:srgbClr val="323232"/>
                 </a:solidFill>
               </a:rPr>
               <a:t/>
@@ -5037,7 +5037,7 @@
             <a:r>
               <a:rPr>
                 <a:solidFill>
-                  <a:srgbClr val="3C3C3C"/>
+                  <a:srgbClr val="323232"/>
                 </a:solidFill>
               </a:rPr>
               <a:t> Converted the final model to the highly optimized ONNX format for lightweight, rapid execution.</a:t>
@@ -5048,14 +5048,14 @@
               <a:spcBef>
                 <a:spcPts val="800"/>
               </a:spcBef>
-              <a:defRPr sz="1500">
-                <a:latin typeface="Calibri"/>
-              </a:defRPr>
-            </a:pPr>
-            <a:r>
-              <a:rPr>
-                <a:solidFill>
-                  <a:srgbClr val="3C3C3C"/>
+              <a:defRPr sz="1800">
+                <a:latin typeface="Calibri"/>
+              </a:defRPr>
+            </a:pPr>
+            <a:r>
+              <a:rPr>
+                <a:solidFill>
+                  <a:srgbClr val="323232"/>
                 </a:solidFill>
               </a:rPr>
               <a:t/>
@@ -5071,7 +5071,7 @@
             <a:r>
               <a:rPr>
                 <a:solidFill>
-                  <a:srgbClr val="3C3C3C"/>
+                  <a:srgbClr val="323232"/>
                 </a:solidFill>
               </a:rPr>
               <a:t> Deployed as a web application using Gradio on Hugging Face Spaces for real-time predictions.</a:t>
@@ -5082,14 +5082,14 @@
               <a:spcBef>
                 <a:spcPts val="800"/>
               </a:spcBef>
-              <a:defRPr sz="1500">
-                <a:latin typeface="Calibri"/>
-              </a:defRPr>
-            </a:pPr>
-            <a:r>
-              <a:rPr>
-                <a:solidFill>
-                  <a:srgbClr val="3C3C3C"/>
+              <a:defRPr sz="1800">
+                <a:latin typeface="Calibri"/>
+              </a:defRPr>
+            </a:pPr>
+            <a:r>
+              <a:rPr>
+                <a:solidFill>
+                  <a:srgbClr val="323232"/>
                 </a:solidFill>
               </a:rPr>
               <a:t/>
@@ -5105,7 +5105,7 @@
             <a:r>
               <a:rPr>
                 <a:solidFill>
-                  <a:srgbClr val="3C3C3C"/>
+                  <a:srgbClr val="323232"/>
                 </a:solidFill>
               </a:rPr>
               <a:t> Assists radiologists by providing a rapid second opinion and prioritizing scanning queues.</a:t>
@@ -5154,7 +5154,7 @@
           <a:lstStyle/>
           <a:p>
             <a:pPr>
-              <a:defRPr sz="2800" b="1">
+              <a:defRPr sz="3600" b="1">
                 <a:solidFill>
                   <a:srgbClr val="003366"/>
                 </a:solidFill>
@@ -5175,8 +5175,8 @@
         </p:nvSpPr>
         <p:spPr>
           <a:xfrm>
-            <a:off x="731520" y="1097280"/>
-            <a:ext cx="10728655" cy="18288"/>
+            <a:off x="731520" y="1188720"/>
+            <a:ext cx="10728655" cy="27432"/>
           </a:xfrm>
           <a:prstGeom prst="rect">
             <a:avLst/>
@@ -5235,7 +5235,7 @@
           <a:lstStyle/>
           <a:p>
             <a:pPr algn="r">
-              <a:defRPr sz="1000">
+              <a:defRPr sz="1200">
                 <a:solidFill>
                   <a:srgbClr val="808080"/>
                 </a:solidFill>
@@ -5274,14 +5274,14 @@
               <a:spcBef>
                 <a:spcPts val="1000"/>
               </a:spcBef>
-              <a:defRPr sz="1500">
-                <a:latin typeface="Calibri"/>
-              </a:defRPr>
-            </a:pPr>
-            <a:r>
-              <a:rPr>
-                <a:solidFill>
-                  <a:srgbClr val="3C3C3C"/>
+              <a:defRPr sz="1800">
+                <a:latin typeface="Calibri"/>
+              </a:defRPr>
+            </a:pPr>
+            <a:r>
+              <a:rPr>
+                <a:solidFill>
+                  <a:srgbClr val="323232"/>
                 </a:solidFill>
               </a:rPr>
               <a:t/>
@@ -5297,10 +5297,10 @@
             <a:r>
               <a:rPr>
                 <a:solidFill>
-                  <a:srgbClr val="3C3C3C"/>
-                </a:solidFill>
-              </a:rPr>
-              <a:t> Manual review of MRI scans by radiologists is time-consuming, prone to human fatigue, and suffers from inter-observer variability.</a:t>
+                  <a:srgbClr val="323232"/>
+                </a:solidFill>
+              </a:rPr>
+              <a:t> Review of MRI scans is time-consuming, prone to human fatigue, and suffers from inter-observer variability.</a:t>
             </a:r>
           </a:p>
           <a:p>
@@ -5308,14 +5308,14 @@
               <a:spcBef>
                 <a:spcPts val="1000"/>
               </a:spcBef>
-              <a:defRPr sz="1500">
-                <a:latin typeface="Calibri"/>
-              </a:defRPr>
-            </a:pPr>
-            <a:r>
-              <a:rPr>
-                <a:solidFill>
-                  <a:srgbClr val="3C3C3C"/>
+              <a:defRPr sz="1800">
+                <a:latin typeface="Calibri"/>
+              </a:defRPr>
+            </a:pPr>
+            <a:r>
+              <a:rPr>
+                <a:solidFill>
+                  <a:srgbClr val="323232"/>
                 </a:solidFill>
               </a:rPr>
               <a:t/>
@@ -5331,7 +5331,7 @@
             <a:r>
               <a:rPr>
                 <a:solidFill>
-                  <a:srgbClr val="3C3C3C"/>
+                  <a:srgbClr val="323232"/>
                 </a:solidFill>
               </a:rPr>
               <a:t> Delays in reading scans postpone treatment decisions for critical conditions like Glioma and Meningioma.</a:t>
@@ -5342,14 +5342,14 @@
               <a:spcBef>
                 <a:spcPts val="1000"/>
               </a:spcBef>
-              <a:defRPr sz="1500">
-                <a:latin typeface="Calibri"/>
-              </a:defRPr>
-            </a:pPr>
-            <a:r>
-              <a:rPr>
-                <a:solidFill>
-                  <a:srgbClr val="3C3C3C"/>
+              <a:defRPr sz="1800">
+                <a:latin typeface="Calibri"/>
+              </a:defRPr>
+            </a:pPr>
+            <a:r>
+              <a:rPr>
+                <a:solidFill>
+                  <a:srgbClr val="323232"/>
                 </a:solidFill>
               </a:rPr>
               <a:t/>
@@ -5365,7 +5365,7 @@
             <a:r>
               <a:rPr>
                 <a:solidFill>
-                  <a:srgbClr val="3C3C3C"/>
+                  <a:srgbClr val="323232"/>
                 </a:solidFill>
               </a:rPr>
               <a:t> Hospitals lack tools that provide standardized, quantitative, and rapid visual validation of tumor boundaries.</a:t>
@@ -5376,14 +5376,14 @@
               <a:spcBef>
                 <a:spcPts val="1000"/>
               </a:spcBef>
-              <a:defRPr sz="1500">
-                <a:latin typeface="Calibri"/>
-              </a:defRPr>
-            </a:pPr>
-            <a:r>
-              <a:rPr>
-                <a:solidFill>
-                  <a:srgbClr val="3C3C3C"/>
+              <a:defRPr sz="1800">
+                <a:latin typeface="Calibri"/>
+              </a:defRPr>
+            </a:pPr>
+            <a:r>
+              <a:rPr>
+                <a:solidFill>
+                  <a:srgbClr val="323232"/>
                 </a:solidFill>
               </a:rPr>
               <a:t/>
@@ -5399,10 +5399,10 @@
             <a:r>
               <a:rPr>
                 <a:solidFill>
-                  <a:srgbClr val="3C3C3C"/>
-                </a:solidFill>
-              </a:rPr>
-              <a:t> Standard deep learning models classify images without explanation, which limits clinical trust and deployment readiness.</a:t>
+                  <a:srgbClr val="323232"/>
+                </a:solidFill>
+              </a:rPr>
+              <a:t> Standard deep learning models classify images without explanation, limiting clinical trust and deployment readiness.</a:t>
             </a:r>
           </a:p>
           <a:p>
@@ -5410,14 +5410,14 @@
               <a:spcBef>
                 <a:spcPts val="1000"/>
               </a:spcBef>
-              <a:defRPr sz="1500">
-                <a:latin typeface="Calibri"/>
-              </a:defRPr>
-            </a:pPr>
-            <a:r>
-              <a:rPr>
-                <a:solidFill>
-                  <a:srgbClr val="3C3C3C"/>
+              <a:defRPr sz="1800">
+                <a:latin typeface="Calibri"/>
+              </a:defRPr>
+            </a:pPr>
+            <a:r>
+              <a:rPr>
+                <a:solidFill>
+                  <a:srgbClr val="323232"/>
                 </a:solidFill>
               </a:rPr>
               <a:t/>
@@ -5433,10 +5433,10 @@
             <a:r>
               <a:rPr>
                 <a:solidFill>
-                  <a:srgbClr val="3C3C3C"/>
-                </a:solidFill>
-              </a:rPr>
-              <a:t> The lack of automated, secondary verification systems leads to missed anomalies and higher workload in radiology departments.</a:t>
+                  <a:srgbClr val="323232"/>
+                </a:solidFill>
+              </a:rPr>
+              <a:t> The lack of automated, secondary verification systems leads to missed anomalies and higher workload in radiology.</a:t>
             </a:r>
           </a:p>
         </p:txBody>
@@ -5494,8 +5494,8 @@
         </p:nvSpPr>
         <p:spPr>
           <a:xfrm>
-            <a:off x="8138160" y="1828800"/>
-            <a:ext cx="3200400" cy="3749039"/>
+            <a:off x="8138160" y="2011680"/>
+            <a:ext cx="3200400" cy="3566160"/>
           </a:xfrm>
           <a:prstGeom prst="rect">
             <a:avLst/>
@@ -5509,10 +5509,7 @@
           <a:lstStyle/>
           <a:p>
             <a:pPr algn="ctr">
-              <a:spcBef>
-                <a:spcPts val="2000"/>
-              </a:spcBef>
-              <a:defRPr sz="1600" b="1">
+              <a:defRPr sz="1800" b="1">
                 <a:solidFill>
                   <a:srgbClr val="003366"/>
                 </a:solidFill>
@@ -5522,6 +5519,7 @@
             <a:r>
               <a:t>Goal:</a:t>
             </a:r>
+            <a:br/>
             <a:br/>
             <a:r>
               <a:t>To build a highly accurate, lightweight, and explainable neural classifier that helps clinicians detect, categorize, and locate tumors on MRI scans instantly.</a:t>
@@ -5570,7 +5568,7 @@
           <a:lstStyle/>
           <a:p>
             <a:pPr>
-              <a:defRPr sz="2800" b="1">
+              <a:defRPr sz="3600" b="1">
                 <a:solidFill>
                   <a:srgbClr val="003366"/>
                 </a:solidFill>
@@ -5591,8 +5589,8 @@
         </p:nvSpPr>
         <p:spPr>
           <a:xfrm>
-            <a:off x="731520" y="1097280"/>
-            <a:ext cx="10728655" cy="18288"/>
+            <a:off x="731520" y="1188720"/>
+            <a:ext cx="10728655" cy="27432"/>
           </a:xfrm>
           <a:prstGeom prst="rect">
             <a:avLst/>
@@ -5651,7 +5649,7 @@
           <a:lstStyle/>
           <a:p>
             <a:pPr algn="r">
-              <a:defRPr sz="1000">
+              <a:defRPr sz="1200">
                 <a:solidFill>
                   <a:srgbClr val="808080"/>
                 </a:solidFill>
@@ -5688,16 +5686,16 @@
           <a:p>
             <a:pPr>
               <a:spcBef>
-                <a:spcPts val="1000"/>
-              </a:spcBef>
-              <a:defRPr sz="1500">
-                <a:latin typeface="Calibri"/>
-              </a:defRPr>
-            </a:pPr>
-            <a:r>
-              <a:rPr>
-                <a:solidFill>
-                  <a:srgbClr val="3C3C3C"/>
+                <a:spcPts val="1200"/>
+              </a:spcBef>
+              <a:defRPr sz="1800">
+                <a:latin typeface="Calibri"/>
+              </a:defRPr>
+            </a:pPr>
+            <a:r>
+              <a:rPr>
+                <a:solidFill>
+                  <a:srgbClr val="323232"/>
                 </a:solidFill>
               </a:rPr>
               <a:t/>
@@ -5713,7 +5711,7 @@
             <a:r>
               <a:rPr>
                 <a:solidFill>
-                  <a:srgbClr val="3C3C3C"/>
+                  <a:srgbClr val="323232"/>
                 </a:solidFill>
               </a:rPr>
               <a:t> Correctly categorize brain MRI scans into four classes: Glioma, Meningioma, Pituitary, or No Tumor.</a:t>
@@ -5722,16 +5720,16 @@
           <a:p>
             <a:pPr>
               <a:spcBef>
-                <a:spcPts val="1000"/>
-              </a:spcBef>
-              <a:defRPr sz="1500">
-                <a:latin typeface="Calibri"/>
-              </a:defRPr>
-            </a:pPr>
-            <a:r>
-              <a:rPr>
-                <a:solidFill>
-                  <a:srgbClr val="3C3C3C"/>
+                <a:spcPts val="1200"/>
+              </a:spcBef>
+              <a:defRPr sz="1800">
+                <a:latin typeface="Calibri"/>
+              </a:defRPr>
+            </a:pPr>
+            <a:r>
+              <a:rPr>
+                <a:solidFill>
+                  <a:srgbClr val="323232"/>
                 </a:solidFill>
               </a:rPr>
               <a:t/>
@@ -5747,7 +5745,7 @@
             <a:r>
               <a:rPr>
                 <a:solidFill>
-                  <a:srgbClr val="3C3C3C"/>
+                  <a:srgbClr val="323232"/>
                 </a:solidFill>
               </a:rPr>
               <a:t> Train and refine an ImageNet-pretrained EfficientNetB0 backbone to achieve rapid convergence and high generalizability on small datasets.</a:t>
@@ -5756,16 +5754,16 @@
           <a:p>
             <a:pPr>
               <a:spcBef>
-                <a:spcPts val="1000"/>
-              </a:spcBef>
-              <a:defRPr sz="1500">
-                <a:latin typeface="Calibri"/>
-              </a:defRPr>
-            </a:pPr>
-            <a:r>
-              <a:rPr>
-                <a:solidFill>
-                  <a:srgbClr val="3C3C3C"/>
+                <a:spcPts val="1200"/>
+              </a:spcBef>
+              <a:defRPr sz="1800">
+                <a:latin typeface="Calibri"/>
+              </a:defRPr>
+            </a:pPr>
+            <a:r>
+              <a:rPr>
+                <a:solidFill>
+                  <a:srgbClr val="323232"/>
                 </a:solidFill>
               </a:rPr>
               <a:t/>
@@ -5781,7 +5779,7 @@
             <a:r>
               <a:rPr>
                 <a:solidFill>
-                  <a:srgbClr val="3C3C3C"/>
+                  <a:srgbClr val="323232"/>
                 </a:solidFill>
               </a:rPr>
               <a:t> Integrate advanced data augmentation, learning rate callbacks, batch normalization, and dropout to eliminate model overfitting.</a:t>
@@ -5790,16 +5788,16 @@
           <a:p>
             <a:pPr>
               <a:spcBef>
-                <a:spcPts val="1000"/>
-              </a:spcBef>
-              <a:defRPr sz="1500">
-                <a:latin typeface="Calibri"/>
-              </a:defRPr>
-            </a:pPr>
-            <a:r>
-              <a:rPr>
-                <a:solidFill>
-                  <a:srgbClr val="3C3C3C"/>
+                <a:spcPts val="1200"/>
+              </a:spcBef>
+              <a:defRPr sz="1800">
+                <a:latin typeface="Calibri"/>
+              </a:defRPr>
+            </a:pPr>
+            <a:r>
+              <a:rPr>
+                <a:solidFill>
+                  <a:srgbClr val="323232"/>
                 </a:solidFill>
               </a:rPr>
               <a:t/>
@@ -5815,7 +5813,7 @@
             <a:r>
               <a:rPr>
                 <a:solidFill>
-                  <a:srgbClr val="3C3C3C"/>
+                  <a:srgbClr val="323232"/>
                 </a:solidFill>
               </a:rPr>
               <a:t> Develop a Grad-CAM pipeline to highlight specific convolutional feature areas to justify predictions visually.</a:t>
@@ -5824,16 +5822,16 @@
           <a:p>
             <a:pPr>
               <a:spcBef>
-                <a:spcPts val="1000"/>
-              </a:spcBef>
-              <a:defRPr sz="1500">
-                <a:latin typeface="Calibri"/>
-              </a:defRPr>
-            </a:pPr>
-            <a:r>
-              <a:rPr>
-                <a:solidFill>
-                  <a:srgbClr val="3C3C3C"/>
+                <a:spcPts val="1200"/>
+              </a:spcBef>
+              <a:defRPr sz="1800">
+                <a:latin typeface="Calibri"/>
+              </a:defRPr>
+            </a:pPr>
+            <a:r>
+              <a:rPr>
+                <a:solidFill>
+                  <a:srgbClr val="323232"/>
                 </a:solidFill>
               </a:rPr>
               <a:t/>
@@ -5849,7 +5847,7 @@
             <a:r>
               <a:rPr>
                 <a:solidFill>
-                  <a:srgbClr val="3C3C3C"/>
+                  <a:srgbClr val="323232"/>
                 </a:solidFill>
               </a:rPr>
               <a:t> Convert Keras models to ONNX and deploy a lightweight, real-time Gradio demo on Hugging Face Spaces.</a:t>
@@ -5898,7 +5896,7 @@
           <a:lstStyle/>
           <a:p>
             <a:pPr>
-              <a:defRPr sz="2800" b="1">
+              <a:defRPr sz="3600" b="1">
                 <a:solidFill>
                   <a:srgbClr val="003366"/>
                 </a:solidFill>
@@ -5919,8 +5917,8 @@
         </p:nvSpPr>
         <p:spPr>
           <a:xfrm>
-            <a:off x="731520" y="1097280"/>
-            <a:ext cx="10728655" cy="18288"/>
+            <a:off x="731520" y="1188720"/>
+            <a:ext cx="10728655" cy="27432"/>
           </a:xfrm>
           <a:prstGeom prst="rect">
             <a:avLst/>
@@ -5979,7 +5977,7 @@
           <a:lstStyle/>
           <a:p>
             <a:pPr algn="r">
-              <a:defRPr sz="1000">
+              <a:defRPr sz="1200">
                 <a:solidFill>
                   <a:srgbClr val="808080"/>
                 </a:solidFill>
@@ -6018,6 +6016,108 @@
               <a:spcBef>
                 <a:spcPts val="600"/>
               </a:spcBef>
+              <a:defRPr sz="1800">
+                <a:latin typeface="Calibri"/>
+              </a:defRPr>
+            </a:pPr>
+            <a:r>
+              <a:rPr>
+                <a:solidFill>
+                  <a:srgbClr val="323232"/>
+                </a:solidFill>
+              </a:rPr>
+              <a:t/>
+            </a:r>
+            <a:r>
+              <a:rPr b="1">
+                <a:solidFill>
+                  <a:srgbClr val="003366"/>
+                </a:solidFill>
+              </a:rPr>
+              <a:t>Source:</a:t>
+            </a:r>
+            <a:r>
+              <a:rPr>
+                <a:solidFill>
+                  <a:srgbClr val="323232"/>
+                </a:solidFill>
+              </a:rPr>
+              <a:t> Brain Tumor MRI Dataset by Masoud Nickparvar (Kaggle).</a:t>
+            </a:r>
+          </a:p>
+          <a:p>
+            <a:pPr>
+              <a:spcBef>
+                <a:spcPts val="600"/>
+              </a:spcBef>
+              <a:defRPr sz="1800">
+                <a:latin typeface="Calibri"/>
+              </a:defRPr>
+            </a:pPr>
+            <a:r>
+              <a:rPr>
+                <a:solidFill>
+                  <a:srgbClr val="323232"/>
+                </a:solidFill>
+              </a:rPr>
+              <a:t/>
+            </a:r>
+            <a:r>
+              <a:rPr b="1">
+                <a:solidFill>
+                  <a:srgbClr val="003366"/>
+                </a:solidFill>
+              </a:rPr>
+              <a:t>Total Size:</a:t>
+            </a:r>
+            <a:r>
+              <a:rPr>
+                <a:solidFill>
+                  <a:srgbClr val="323232"/>
+                </a:solidFill>
+              </a:rPr>
+              <a:t> 7,023 high-quality brain MRI scans.</a:t>
+            </a:r>
+          </a:p>
+          <a:p>
+            <a:pPr>
+              <a:spcBef>
+                <a:spcPts val="600"/>
+              </a:spcBef>
+              <a:defRPr sz="1800">
+                <a:latin typeface="Calibri"/>
+              </a:defRPr>
+            </a:pPr>
+            <a:r>
+              <a:rPr>
+                <a:solidFill>
+                  <a:srgbClr val="323232"/>
+                </a:solidFill>
+              </a:rPr>
+              <a:t/>
+            </a:r>
+            <a:r>
+              <a:rPr b="1">
+                <a:solidFill>
+                  <a:srgbClr val="003366"/>
+                </a:solidFill>
+              </a:rPr>
+              <a:t>Data Splitting Strategy:</a:t>
+            </a:r>
+            <a:r>
+              <a:rPr>
+                <a:solidFill>
+                  <a:srgbClr val="323232"/>
+                </a:solidFill>
+              </a:rPr>
+              <a:t/>
+            </a:r>
+          </a:p>
+          <a:p>
+            <a:pPr>
+              <a:spcBef>
+                <a:spcPts val="600"/>
+              </a:spcBef>
               <a:defRPr sz="1500">
                 <a:latin typeface="Calibri"/>
               </a:defRPr>
@@ -6025,26 +6125,96 @@
             <a:r>
               <a:rPr>
                 <a:solidFill>
-                  <a:srgbClr val="3C3C3C"/>
+                  <a:srgbClr val="323232"/>
+                </a:solidFill>
+              </a:rPr>
+              <a:t>  - </a:t>
+            </a:r>
+            <a:r>
+              <a:rPr b="1">
+                <a:solidFill>
+                  <a:srgbClr val="003366"/>
+                </a:solidFill>
+              </a:rPr>
+              <a:t>Training Set (5,712 images):</a:t>
+            </a:r>
+            <a:r>
+              <a:rPr>
+                <a:solidFill>
+                  <a:srgbClr val="323232"/>
                 </a:solidFill>
               </a:rPr>
               <a:t/>
             </a:r>
+          </a:p>
+          <a:p>
+            <a:pPr>
+              <a:spcBef>
+                <a:spcPts val="600"/>
+              </a:spcBef>
+              <a:defRPr sz="1500">
+                <a:latin typeface="Calibri"/>
+              </a:defRPr>
+            </a:pPr>
+            <a:r>
+              <a:rPr>
+                <a:solidFill>
+                  <a:srgbClr val="323232"/>
+                </a:solidFill>
+              </a:rPr>
+              <a:t>    Glioma: 1,321 | Meningioma: 1,339</a:t>
+            </a:r>
+          </a:p>
+          <a:p>
+            <a:pPr>
+              <a:spcBef>
+                <a:spcPts val="600"/>
+              </a:spcBef>
+              <a:defRPr sz="1800">
+                <a:latin typeface="Calibri"/>
+              </a:defRPr>
+            </a:pPr>
+            <a:r>
+              <a:rPr>
+                <a:solidFill>
+                  <a:srgbClr val="323232"/>
+                </a:solidFill>
+              </a:rPr>
+              <a:t>    Pituitary: 1,457 | No Tumor: 1,595</a:t>
+            </a:r>
+          </a:p>
+          <a:p>
+            <a:pPr>
+              <a:spcBef>
+                <a:spcPts val="600"/>
+              </a:spcBef>
+              <a:defRPr sz="1500">
+                <a:latin typeface="Calibri"/>
+              </a:defRPr>
+            </a:pPr>
+            <a:r>
+              <a:rPr>
+                <a:solidFill>
+                  <a:srgbClr val="323232"/>
+                </a:solidFill>
+              </a:rPr>
+              <a:t>  - </a:t>
+            </a:r>
             <a:r>
               <a:rPr b="1">
                 <a:solidFill>
                   <a:srgbClr val="003366"/>
                 </a:solidFill>
               </a:rPr>
-              <a:t>Source:</a:t>
-            </a:r>
-            <a:r>
-              <a:rPr>
-                <a:solidFill>
-                  <a:srgbClr val="3C3C3C"/>
-                </a:solidFill>
-              </a:rPr>
-              <a:t> Brain Tumor MRI Dataset by Masoud Nickparvar (Kaggle).</a:t>
+              <a:t>Testing Set (1,311 images):</a:t>
+            </a:r>
+            <a:r>
+              <a:rPr>
+                <a:solidFill>
+                  <a:srgbClr val="323232"/>
+                </a:solidFill>
+              </a:rPr>
+              <a:t/>
             </a:r>
           </a:p>
           <a:p>
@@ -6059,7 +6229,43 @@
             <a:r>
               <a:rPr>
                 <a:solidFill>
-                  <a:srgbClr val="3C3C3C"/>
+                  <a:srgbClr val="323232"/>
+                </a:solidFill>
+              </a:rPr>
+              <a:t>    Glioma: 300 | Meningioma: 306</a:t>
+            </a:r>
+          </a:p>
+          <a:p>
+            <a:pPr>
+              <a:spcBef>
+                <a:spcPts val="600"/>
+              </a:spcBef>
+              <a:defRPr sz="1800">
+                <a:latin typeface="Calibri"/>
+              </a:defRPr>
+            </a:pPr>
+            <a:r>
+              <a:rPr>
+                <a:solidFill>
+                  <a:srgbClr val="323232"/>
+                </a:solidFill>
+              </a:rPr>
+              <a:t>    Pituitary: 300 | No Tumor: 405</a:t>
+            </a:r>
+          </a:p>
+          <a:p>
+            <a:pPr>
+              <a:spcBef>
+                <a:spcPts val="600"/>
+              </a:spcBef>
+              <a:defRPr sz="1800">
+                <a:latin typeface="Calibri"/>
+              </a:defRPr>
+            </a:pPr>
+            <a:r>
+              <a:rPr>
+                <a:solidFill>
+                  <a:srgbClr val="323232"/>
                 </a:solidFill>
               </a:rPr>
               <a:t/>
@@ -6070,15 +6276,15 @@
                   <a:srgbClr val="003366"/>
                 </a:solidFill>
               </a:rPr>
-              <a:t>Total Size:</a:t>
-            </a:r>
-            <a:r>
-              <a:rPr>
-                <a:solidFill>
-                  <a:srgbClr val="3C3C3C"/>
-                </a:solidFill>
-              </a:rPr>
-              <a:t> 7,023 high-quality brain MRI scans.</a:t>
+              <a:t>Resolution:</a:t>
+            </a:r>
+            <a:r>
+              <a:rPr>
+                <a:solidFill>
+                  <a:srgbClr val="323232"/>
+                </a:solidFill>
+              </a:rPr>
+              <a:t> Resized to 224 × 224 pixels with 3 color channels (RGB).</a:t>
             </a:r>
           </a:p>
           <a:p>
@@ -6086,14 +6292,14 @@
               <a:spcBef>
                 <a:spcPts val="600"/>
               </a:spcBef>
-              <a:defRPr sz="1500">
-                <a:latin typeface="Calibri"/>
-              </a:defRPr>
-            </a:pPr>
-            <a:r>
-              <a:rPr>
-                <a:solidFill>
-                  <a:srgbClr val="3C3C3C"/>
+              <a:defRPr sz="1800">
+                <a:latin typeface="Calibri"/>
+              </a:defRPr>
+            </a:pPr>
+            <a:r>
+              <a:rPr>
+                <a:solidFill>
+                  <a:srgbClr val="323232"/>
                 </a:solidFill>
               </a:rPr>
               <a:t/>
@@ -6104,220 +6310,12 @@
                   <a:srgbClr val="003366"/>
                 </a:solidFill>
               </a:rPr>
-              <a:t>Data Splitting Strategy:</a:t>
-            </a:r>
-            <a:r>
-              <a:rPr>
-                <a:solidFill>
-                  <a:srgbClr val="3C3C3C"/>
-                </a:solidFill>
-              </a:rPr>
-              <a:t/>
-            </a:r>
-          </a:p>
-          <a:p>
-            <a:pPr>
-              <a:spcBef>
-                <a:spcPts val="600"/>
-              </a:spcBef>
-              <a:defRPr sz="1300">
-                <a:latin typeface="Calibri"/>
-              </a:defRPr>
-            </a:pPr>
-            <a:r>
-              <a:rPr>
-                <a:solidFill>
-                  <a:srgbClr val="3C3C3C"/>
-                </a:solidFill>
-              </a:rPr>
-              <a:t>  - </a:t>
-            </a:r>
-            <a:r>
-              <a:rPr b="1">
-                <a:solidFill>
-                  <a:srgbClr val="003366"/>
-                </a:solidFill>
-              </a:rPr>
-              <a:t>Training Set (5,712 images):</a:t>
-            </a:r>
-            <a:r>
-              <a:rPr>
-                <a:solidFill>
-                  <a:srgbClr val="3C3C3C"/>
-                </a:solidFill>
-              </a:rPr>
-              <a:t/>
-            </a:r>
-          </a:p>
-          <a:p>
-            <a:pPr>
-              <a:spcBef>
-                <a:spcPts val="600"/>
-              </a:spcBef>
-              <a:defRPr sz="1300">
-                <a:latin typeface="Calibri"/>
-              </a:defRPr>
-            </a:pPr>
-            <a:r>
-              <a:rPr>
-                <a:solidFill>
-                  <a:srgbClr val="3C3C3C"/>
-                </a:solidFill>
-              </a:rPr>
-              <a:t>    - Glioma: 1,321 | Meningioma: 1,339</a:t>
-            </a:r>
-          </a:p>
-          <a:p>
-            <a:pPr>
-              <a:spcBef>
-                <a:spcPts val="600"/>
-              </a:spcBef>
-              <a:defRPr sz="1300">
-                <a:latin typeface="Calibri"/>
-              </a:defRPr>
-            </a:pPr>
-            <a:r>
-              <a:rPr>
-                <a:solidFill>
-                  <a:srgbClr val="3C3C3C"/>
-                </a:solidFill>
-              </a:rPr>
-              <a:t>    - Pituitary: 1,457 | No Tumor: 1,595</a:t>
-            </a:r>
-          </a:p>
-          <a:p>
-            <a:pPr>
-              <a:spcBef>
-                <a:spcPts val="600"/>
-              </a:spcBef>
-              <a:defRPr sz="1300">
-                <a:latin typeface="Calibri"/>
-              </a:defRPr>
-            </a:pPr>
-            <a:r>
-              <a:rPr>
-                <a:solidFill>
-                  <a:srgbClr val="3C3C3C"/>
-                </a:solidFill>
-              </a:rPr>
-              <a:t>  - </a:t>
-            </a:r>
-            <a:r>
-              <a:rPr b="1">
-                <a:solidFill>
-                  <a:srgbClr val="003366"/>
-                </a:solidFill>
-              </a:rPr>
-              <a:t>Testing Set (1,311 images):</a:t>
-            </a:r>
-            <a:r>
-              <a:rPr>
-                <a:solidFill>
-                  <a:srgbClr val="3C3C3C"/>
-                </a:solidFill>
-              </a:rPr>
-              <a:t/>
-            </a:r>
-          </a:p>
-          <a:p>
-            <a:pPr>
-              <a:spcBef>
-                <a:spcPts val="600"/>
-              </a:spcBef>
-              <a:defRPr sz="1300">
-                <a:latin typeface="Calibri"/>
-              </a:defRPr>
-            </a:pPr>
-            <a:r>
-              <a:rPr>
-                <a:solidFill>
-                  <a:srgbClr val="3C3C3C"/>
-                </a:solidFill>
-              </a:rPr>
-              <a:t>    - Glioma: 300 | Meningioma: 306</a:t>
-            </a:r>
-          </a:p>
-          <a:p>
-            <a:pPr>
-              <a:spcBef>
-                <a:spcPts val="600"/>
-              </a:spcBef>
-              <a:defRPr sz="1300">
-                <a:latin typeface="Calibri"/>
-              </a:defRPr>
-            </a:pPr>
-            <a:r>
-              <a:rPr>
-                <a:solidFill>
-                  <a:srgbClr val="3C3C3C"/>
-                </a:solidFill>
-              </a:rPr>
-              <a:t>    - Pituitary: 300 | No Tumor: 405</a:t>
-            </a:r>
-          </a:p>
-          <a:p>
-            <a:pPr>
-              <a:spcBef>
-                <a:spcPts val="600"/>
-              </a:spcBef>
-              <a:defRPr sz="1500">
-                <a:latin typeface="Calibri"/>
-              </a:defRPr>
-            </a:pPr>
-            <a:r>
-              <a:rPr>
-                <a:solidFill>
-                  <a:srgbClr val="3C3C3C"/>
-                </a:solidFill>
-              </a:rPr>
-              <a:t/>
-            </a:r>
-            <a:r>
-              <a:rPr b="1">
-                <a:solidFill>
-                  <a:srgbClr val="003366"/>
-                </a:solidFill>
-              </a:rPr>
-              <a:t>Resolution:</a:t>
-            </a:r>
-            <a:r>
-              <a:rPr>
-                <a:solidFill>
-                  <a:srgbClr val="3C3C3C"/>
-                </a:solidFill>
-              </a:rPr>
-              <a:t> Resized to 224 × 224 pixels with 3 color channels (RGB).</a:t>
-            </a:r>
-          </a:p>
-          <a:p>
-            <a:pPr>
-              <a:spcBef>
-                <a:spcPts val="600"/>
-              </a:spcBef>
-              <a:defRPr sz="1500">
-                <a:latin typeface="Calibri"/>
-              </a:defRPr>
-            </a:pPr>
-            <a:r>
-              <a:rPr>
-                <a:solidFill>
-                  <a:srgbClr val="3C3C3C"/>
-                </a:solidFill>
-              </a:rPr>
-              <a:t/>
-            </a:r>
-            <a:r>
-              <a:rPr b="1">
-                <a:solidFill>
-                  <a:srgbClr val="003366"/>
-                </a:solidFill>
-              </a:rPr>
               <a:t>Validation:</a:t>
             </a:r>
             <a:r>
               <a:rPr>
                 <a:solidFill>
-                  <a:srgbClr val="3C3C3C"/>
+                  <a:srgbClr val="323232"/>
                 </a:solidFill>
               </a:rPr>
               <a:t> 20% validation split taken from the training set dynamically during model fit.</a:t>
@@ -6348,7 +6346,7 @@
           <a:lstStyle/>
           <a:p>
             <a:pPr algn="ctr">
-              <a:defRPr sz="1400" b="1">
+              <a:defRPr sz="1800" b="1">
                 <a:solidFill>
                   <a:srgbClr val="003366"/>
                 </a:solidFill>
@@ -6426,7 +6424,7 @@
           <a:lstStyle/>
           <a:p>
             <a:pPr>
-              <a:defRPr sz="2800" b="1">
+              <a:defRPr sz="3600" b="1">
                 <a:solidFill>
                   <a:srgbClr val="003366"/>
                 </a:solidFill>
@@ -6447,8 +6445,8 @@
         </p:nvSpPr>
         <p:spPr>
           <a:xfrm>
-            <a:off x="731520" y="1097280"/>
-            <a:ext cx="10728655" cy="18288"/>
+            <a:off x="731520" y="1188720"/>
+            <a:ext cx="10728655" cy="27432"/>
           </a:xfrm>
           <a:prstGeom prst="rect">
             <a:avLst/>
@@ -6507,7 +6505,7 @@
           <a:lstStyle/>
           <a:p>
             <a:pPr algn="r">
-              <a:defRPr sz="1000">
+              <a:defRPr sz="1200">
                 <a:solidFill>
                   <a:srgbClr val="808080"/>
                 </a:solidFill>
@@ -6537,7 +6535,7 @@
           <a:solidFill>
             <a:srgbClr val="E6F0FF"/>
           </a:solidFill>
-          <a:ln w="12700">
+          <a:ln w="19050">
             <a:solidFill>
               <a:srgbClr val="4682B4"/>
             </a:solidFill>
@@ -6562,7 +6560,7 @@
           <a:lstStyle/>
           <a:p>
             <a:pPr algn="ctr">
-              <a:defRPr sz="1300" b="1">
+              <a:defRPr sz="1500" b="1">
                 <a:solidFill>
                   <a:srgbClr val="003366"/>
                 </a:solidFill>
@@ -6578,9 +6576,9 @@
               <a:spcBef>
                 <a:spcPts val="400"/>
               </a:spcBef>
-              <a:defRPr sz="1050">
-                <a:solidFill>
-                  <a:srgbClr val="3C3C3C"/>
+              <a:defRPr sz="1200">
+                <a:solidFill>
+                  <a:srgbClr val="323232"/>
                 </a:solidFill>
                 <a:latin typeface="Calibri"/>
               </a:defRPr>
@@ -6608,7 +6606,7 @@
           <a:solidFill>
             <a:srgbClr val="E6F0FF"/>
           </a:solidFill>
-          <a:ln w="12700">
+          <a:ln w="19050">
             <a:solidFill>
               <a:srgbClr val="4682B4"/>
             </a:solidFill>
@@ -6633,7 +6631,7 @@
           <a:lstStyle/>
           <a:p>
             <a:pPr algn="ctr">
-              <a:defRPr sz="1300" b="1">
+              <a:defRPr sz="1500" b="1">
                 <a:solidFill>
                   <a:srgbClr val="003366"/>
                 </a:solidFill>
@@ -6649,9 +6647,9 @@
               <a:spcBef>
                 <a:spcPts val="400"/>
               </a:spcBef>
-              <a:defRPr sz="1050">
-                <a:solidFill>
-                  <a:srgbClr val="3C3C3C"/>
+              <a:defRPr sz="1200">
+                <a:solidFill>
+                  <a:srgbClr val="323232"/>
                 </a:solidFill>
                 <a:latin typeface="Calibri"/>
               </a:defRPr>
@@ -6679,7 +6677,7 @@
           <a:solidFill>
             <a:srgbClr val="E6F0FF"/>
           </a:solidFill>
-          <a:ln w="12700">
+          <a:ln w="19050">
             <a:solidFill>
               <a:srgbClr val="4682B4"/>
             </a:solidFill>
@@ -6704,7 +6702,7 @@
           <a:lstStyle/>
           <a:p>
             <a:pPr algn="ctr">
-              <a:defRPr sz="1300" b="1">
+              <a:defRPr sz="1500" b="1">
                 <a:solidFill>
                   <a:srgbClr val="003366"/>
                 </a:solidFill>
@@ -6720,9 +6718,9 @@
               <a:spcBef>
                 <a:spcPts val="400"/>
               </a:spcBef>
-              <a:defRPr sz="1050">
-                <a:solidFill>
-                  <a:srgbClr val="3C3C3C"/>
+              <a:defRPr sz="1200">
+                <a:solidFill>
+                  <a:srgbClr val="323232"/>
                 </a:solidFill>
                 <a:latin typeface="Calibri"/>
               </a:defRPr>
@@ -6750,7 +6748,7 @@
           <a:solidFill>
             <a:srgbClr val="E6F0FF"/>
           </a:solidFill>
-          <a:ln w="12700">
+          <a:ln w="19050">
             <a:solidFill>
               <a:srgbClr val="4682B4"/>
             </a:solidFill>
@@ -6775,7 +6773,7 @@
           <a:lstStyle/>
           <a:p>
             <a:pPr algn="ctr">
-              <a:defRPr sz="1300" b="1">
+              <a:defRPr sz="1500" b="1">
                 <a:solidFill>
                   <a:srgbClr val="003366"/>
                 </a:solidFill>
@@ -6791,9 +6789,9 @@
               <a:spcBef>
                 <a:spcPts val="400"/>
               </a:spcBef>
-              <a:defRPr sz="1050">
-                <a:solidFill>
-                  <a:srgbClr val="3C3C3C"/>
+              <a:defRPr sz="1200">
+                <a:solidFill>
+                  <a:srgbClr val="323232"/>
                 </a:solidFill>
                 <a:latin typeface="Calibri"/>
               </a:defRPr>
@@ -6821,7 +6819,7 @@
           <a:solidFill>
             <a:srgbClr val="E6F0FF"/>
           </a:solidFill>
-          <a:ln w="12700">
+          <a:ln w="19050">
             <a:solidFill>
               <a:srgbClr val="4682B4"/>
             </a:solidFill>
@@ -6846,7 +6844,7 @@
           <a:lstStyle/>
           <a:p>
             <a:pPr algn="ctr">
-              <a:defRPr sz="1300" b="1">
+              <a:defRPr sz="1500" b="1">
                 <a:solidFill>
                   <a:srgbClr val="003366"/>
                 </a:solidFill>
@@ -6862,9 +6860,9 @@
               <a:spcBef>
                 <a:spcPts val="400"/>
               </a:spcBef>
-              <a:defRPr sz="1050">
-                <a:solidFill>
-                  <a:srgbClr val="3C3C3C"/>
+              <a:defRPr sz="1200">
+                <a:solidFill>
+                  <a:srgbClr val="323232"/>
                 </a:solidFill>
                 <a:latin typeface="Calibri"/>
               </a:defRPr>
@@ -6892,7 +6890,7 @@
           <a:solidFill>
             <a:srgbClr val="E6F0FF"/>
           </a:solidFill>
-          <a:ln w="12700">
+          <a:ln w="19050">
             <a:solidFill>
               <a:srgbClr val="4682B4"/>
             </a:solidFill>
@@ -6917,7 +6915,7 @@
           <a:lstStyle/>
           <a:p>
             <a:pPr algn="ctr">
-              <a:defRPr sz="1300" b="1">
+              <a:defRPr sz="1500" b="1">
                 <a:solidFill>
                   <a:srgbClr val="003366"/>
                 </a:solidFill>
@@ -6933,9 +6931,9 @@
               <a:spcBef>
                 <a:spcPts val="400"/>
               </a:spcBef>
-              <a:defRPr sz="1050">
-                <a:solidFill>
-                  <a:srgbClr val="3C3C3C"/>
+              <a:defRPr sz="1200">
+                <a:solidFill>
+                  <a:srgbClr val="323232"/>
                 </a:solidFill>
                 <a:latin typeface="Calibri"/>
               </a:defRPr>
@@ -6963,7 +6961,7 @@
           <a:solidFill>
             <a:srgbClr val="E6F0FF"/>
           </a:solidFill>
-          <a:ln w="12700">
+          <a:ln w="19050">
             <a:solidFill>
               <a:srgbClr val="4682B4"/>
             </a:solidFill>
@@ -6988,7 +6986,7 @@
           <a:lstStyle/>
           <a:p>
             <a:pPr algn="ctr">
-              <a:defRPr sz="1300" b="1">
+              <a:defRPr sz="1500" b="1">
                 <a:solidFill>
                   <a:srgbClr val="003366"/>
                 </a:solidFill>
@@ -7004,9 +7002,9 @@
               <a:spcBef>
                 <a:spcPts val="400"/>
               </a:spcBef>
-              <a:defRPr sz="1050">
-                <a:solidFill>
-                  <a:srgbClr val="3C3C3C"/>
+              <a:defRPr sz="1200">
+                <a:solidFill>
+                  <a:srgbClr val="323232"/>
                 </a:solidFill>
                 <a:latin typeface="Calibri"/>
               </a:defRPr>
@@ -7034,7 +7032,7 @@
           <a:solidFill>
             <a:srgbClr val="E6F0FF"/>
           </a:solidFill>
-          <a:ln w="12700">
+          <a:ln w="19050">
             <a:solidFill>
               <a:srgbClr val="4682B4"/>
             </a:solidFill>
@@ -7059,7 +7057,7 @@
           <a:lstStyle/>
           <a:p>
             <a:pPr algn="ctr">
-              <a:defRPr sz="1300" b="1">
+              <a:defRPr sz="1500" b="1">
                 <a:solidFill>
                   <a:srgbClr val="003366"/>
                 </a:solidFill>
@@ -7075,9 +7073,9 @@
               <a:spcBef>
                 <a:spcPts val="400"/>
               </a:spcBef>
-              <a:defRPr sz="1050">
-                <a:solidFill>
-                  <a:srgbClr val="3C3C3C"/>
+              <a:defRPr sz="1200">
+                <a:solidFill>
+                  <a:srgbClr val="323232"/>
                 </a:solidFill>
                 <a:latin typeface="Calibri"/>
               </a:defRPr>
@@ -7105,7 +7103,7 @@
           <a:solidFill>
             <a:srgbClr val="E6F0FF"/>
           </a:solidFill>
-          <a:ln w="12700">
+          <a:ln w="19050">
             <a:solidFill>
               <a:srgbClr val="4682B4"/>
             </a:solidFill>
@@ -7130,7 +7128,7 @@
           <a:lstStyle/>
           <a:p>
             <a:pPr algn="ctr">
-              <a:defRPr sz="1300" b="1">
+              <a:defRPr sz="1500" b="1">
                 <a:solidFill>
                   <a:srgbClr val="003366"/>
                 </a:solidFill>
@@ -7146,9 +7144,9 @@
               <a:spcBef>
                 <a:spcPts val="400"/>
               </a:spcBef>
-              <a:defRPr sz="1050">
-                <a:solidFill>
-                  <a:srgbClr val="3C3C3C"/>
+              <a:defRPr sz="1200">
+                <a:solidFill>
+                  <a:srgbClr val="323232"/>
                 </a:solidFill>
                 <a:latin typeface="Calibri"/>
               </a:defRPr>
@@ -7200,7 +7198,7 @@
           <a:lstStyle/>
           <a:p>
             <a:pPr>
-              <a:defRPr sz="2800" b="1">
+              <a:defRPr sz="3600" b="1">
                 <a:solidFill>
                   <a:srgbClr val="003366"/>
                 </a:solidFill>
@@ -7221,8 +7219,8 @@
         </p:nvSpPr>
         <p:spPr>
           <a:xfrm>
-            <a:off x="731520" y="1097280"/>
-            <a:ext cx="10728655" cy="18288"/>
+            <a:off x="731520" y="1188720"/>
+            <a:ext cx="10728655" cy="27432"/>
           </a:xfrm>
           <a:prstGeom prst="rect">
             <a:avLst/>
@@ -7281,7 +7279,7 @@
           <a:lstStyle/>
           <a:p>
             <a:pPr algn="r">
-              <a:defRPr sz="1000">
+              <a:defRPr sz="1200">
                 <a:solidFill>
                   <a:srgbClr val="808080"/>
                 </a:solidFill>
@@ -7311,7 +7309,7 @@
           <a:solidFill>
             <a:srgbClr val="E6F0FF"/>
           </a:solidFill>
-          <a:ln>
+          <a:ln w="19050">
             <a:solidFill>
               <a:srgbClr val="4682B4"/>
             </a:solidFill>
@@ -7339,7 +7337,7 @@
               <a:spcBef>
                 <a:spcPts val="500"/>
               </a:spcBef>
-              <a:defRPr sz="1800" b="1">
+              <a:defRPr sz="2200" b="1">
                 <a:solidFill>
                   <a:srgbClr val="003366"/>
                 </a:solidFill>
@@ -7355,14 +7353,14 @@
               <a:spcBef>
                 <a:spcPts val="600"/>
               </a:spcBef>
-              <a:defRPr sz="1200">
-                <a:latin typeface="Calibri"/>
-              </a:defRPr>
-            </a:pPr>
-            <a:r>
-              <a:rPr>
-                <a:solidFill>
-                  <a:srgbClr val="3C3C3C"/>
+              <a:defRPr sz="1400">
+                <a:latin typeface="Calibri"/>
+              </a:defRPr>
+            </a:pPr>
+            <a:r>
+              <a:rPr>
+                <a:solidFill>
+                  <a:srgbClr val="323232"/>
                 </a:solidFill>
               </a:rPr>
               <a:t/>
@@ -7378,7 +7376,7 @@
             <a:r>
               <a:rPr>
                 <a:solidFill>
-                  <a:srgbClr val="3C3C3C"/>
+                  <a:srgbClr val="323232"/>
                 </a:solidFill>
               </a:rPr>
               <a:t> Core execution runtime.</a:t>
@@ -7389,14 +7387,14 @@
               <a:spcBef>
                 <a:spcPts val="600"/>
               </a:spcBef>
-              <a:defRPr sz="1200">
-                <a:latin typeface="Calibri"/>
-              </a:defRPr>
-            </a:pPr>
-            <a:r>
-              <a:rPr>
-                <a:solidFill>
-                  <a:srgbClr val="3C3C3C"/>
+              <a:defRPr sz="1400">
+                <a:latin typeface="Calibri"/>
+              </a:defRPr>
+            </a:pPr>
+            <a:r>
+              <a:rPr>
+                <a:solidFill>
+                  <a:srgbClr val="323232"/>
                 </a:solidFill>
               </a:rPr>
               <a:t/>
@@ -7412,7 +7410,7 @@
             <a:r>
               <a:rPr>
                 <a:solidFill>
-                  <a:srgbClr val="3C3C3C"/>
+                  <a:srgbClr val="323232"/>
                 </a:solidFill>
               </a:rPr>
               <a:t> Model building and transfer learning training frameworks.</a:t>
@@ -7423,14 +7421,14 @@
               <a:spcBef>
                 <a:spcPts val="600"/>
               </a:spcBef>
-              <a:defRPr sz="1200">
-                <a:latin typeface="Calibri"/>
-              </a:defRPr>
-            </a:pPr>
-            <a:r>
-              <a:rPr>
-                <a:solidFill>
-                  <a:srgbClr val="3C3C3C"/>
+              <a:defRPr sz="1400">
+                <a:latin typeface="Calibri"/>
+              </a:defRPr>
+            </a:pPr>
+            <a:r>
+              <a:rPr>
+                <a:solidFill>
+                  <a:srgbClr val="323232"/>
                 </a:solidFill>
               </a:rPr>
               <a:t/>
@@ -7446,7 +7444,7 @@
             <a:r>
               <a:rPr>
                 <a:solidFill>
-                  <a:srgbClr val="3C3C3C"/>
+                  <a:srgbClr val="323232"/>
                 </a:solidFill>
               </a:rPr>
               <a:t> Grad-CAM blending and heatmap preprocessing operations.</a:t>
@@ -7457,14 +7455,14 @@
               <a:spcBef>
                 <a:spcPts val="600"/>
               </a:spcBef>
-              <a:defRPr sz="1200">
-                <a:latin typeface="Calibri"/>
-              </a:defRPr>
-            </a:pPr>
-            <a:r>
-              <a:rPr>
-                <a:solidFill>
-                  <a:srgbClr val="3C3C3C"/>
+              <a:defRPr sz="1400">
+                <a:latin typeface="Calibri"/>
+              </a:defRPr>
+            </a:pPr>
+            <a:r>
+              <a:rPr>
+                <a:solidFill>
+                  <a:srgbClr val="323232"/>
                 </a:solidFill>
               </a:rPr>
               <a:t/>
@@ -7480,7 +7478,7 @@
             <a:r>
               <a:rPr>
                 <a:solidFill>
-                  <a:srgbClr val="3C3C3C"/>
+                  <a:srgbClr val="323232"/>
                 </a:solidFill>
               </a:rPr>
               <a:t> Ultra-lightweight inference engine for Gradio deployments.</a:t>
@@ -7491,14 +7489,14 @@
               <a:spcBef>
                 <a:spcPts val="600"/>
               </a:spcBef>
-              <a:defRPr sz="1200">
-                <a:latin typeface="Calibri"/>
-              </a:defRPr>
-            </a:pPr>
-            <a:r>
-              <a:rPr>
-                <a:solidFill>
-                  <a:srgbClr val="3C3C3C"/>
+              <a:defRPr sz="1400">
+                <a:latin typeface="Calibri"/>
+              </a:defRPr>
+            </a:pPr>
+            <a:r>
+              <a:rPr>
+                <a:solidFill>
+                  <a:srgbClr val="323232"/>
                 </a:solidFill>
               </a:rPr>
               <a:t/>
@@ -7514,7 +7512,7 @@
             <a:r>
               <a:rPr>
                 <a:solidFill>
-                  <a:srgbClr val="3C3C3C"/>
+                  <a:srgbClr val="323232"/>
                 </a:solidFill>
               </a:rPr>
               <a:t> Tool used to convert models from Keras to ONNX format.</a:t>
@@ -7525,14 +7523,14 @@
               <a:spcBef>
                 <a:spcPts val="600"/>
               </a:spcBef>
-              <a:defRPr sz="1200">
-                <a:latin typeface="Calibri"/>
-              </a:defRPr>
-            </a:pPr>
-            <a:r>
-              <a:rPr>
-                <a:solidFill>
-                  <a:srgbClr val="3C3C3C"/>
+              <a:defRPr sz="1400">
+                <a:latin typeface="Calibri"/>
+              </a:defRPr>
+            </a:pPr>
+            <a:r>
+              <a:rPr>
+                <a:solidFill>
+                  <a:srgbClr val="323232"/>
                 </a:solidFill>
               </a:rPr>
               <a:t/>
@@ -7548,7 +7546,7 @@
             <a:r>
               <a:rPr>
                 <a:solidFill>
-                  <a:srgbClr val="3C3C3C"/>
+                  <a:srgbClr val="323232"/>
                 </a:solidFill>
               </a:rPr>
               <a:t> Builds interactive web interface components.</a:t>
@@ -7559,14 +7557,14 @@
               <a:spcBef>
                 <a:spcPts val="600"/>
               </a:spcBef>
-              <a:defRPr sz="1200">
-                <a:latin typeface="Calibri"/>
-              </a:defRPr>
-            </a:pPr>
-            <a:r>
-              <a:rPr>
-                <a:solidFill>
-                  <a:srgbClr val="3C3C3C"/>
+              <a:defRPr sz="1400">
+                <a:latin typeface="Calibri"/>
+              </a:defRPr>
+            </a:pPr>
+            <a:r>
+              <a:rPr>
+                <a:solidFill>
+                  <a:srgbClr val="323232"/>
                 </a:solidFill>
               </a:rPr>
               <a:t/>
@@ -7582,7 +7580,7 @@
             <a:r>
               <a:rPr>
                 <a:solidFill>
-                  <a:srgbClr val="3C3C3C"/>
+                  <a:srgbClr val="323232"/>
                 </a:solidFill>
               </a:rPr>
               <a:t> Experimental environments.</a:t>
@@ -7607,7 +7605,7 @@
           <a:solidFill>
             <a:srgbClr val="E6F0FF"/>
           </a:solidFill>
-          <a:ln>
+          <a:ln w="19050">
             <a:solidFill>
               <a:srgbClr val="4682B4"/>
             </a:solidFill>
@@ -7635,7 +7633,7 @@
               <a:spcBef>
                 <a:spcPts val="500"/>
               </a:spcBef>
-              <a:defRPr sz="1800" b="1">
+              <a:defRPr sz="2200" b="1">
                 <a:solidFill>
                   <a:srgbClr val="003366"/>
                 </a:solidFill>
@@ -7651,14 +7649,14 @@
               <a:spcBef>
                 <a:spcPts val="500"/>
               </a:spcBef>
-              <a:defRPr sz="1300">
-                <a:latin typeface="Calibri"/>
-              </a:defRPr>
-            </a:pPr>
-            <a:r>
-              <a:rPr>
-                <a:solidFill>
-                  <a:srgbClr val="3C3C3C"/>
+              <a:defRPr sz="1600">
+                <a:latin typeface="Calibri"/>
+              </a:defRPr>
+            </a:pPr>
+            <a:r>
+              <a:rPr>
+                <a:solidFill>
+                  <a:srgbClr val="323232"/>
                 </a:solidFill>
               </a:rPr>
               <a:t/>
@@ -7674,7 +7672,7 @@
             <a:r>
               <a:rPr>
                 <a:solidFill>
-                  <a:srgbClr val="3C3C3C"/>
+                  <a:srgbClr val="323232"/>
                 </a:solidFill>
               </a:rPr>
               <a:t/>
@@ -7685,14 +7683,14 @@
               <a:spcBef>
                 <a:spcPts val="500"/>
               </a:spcBef>
-              <a:defRPr sz="1200">
-                <a:latin typeface="Calibri"/>
-              </a:defRPr>
-            </a:pPr>
-            <a:r>
-              <a:rPr>
-                <a:solidFill>
-                  <a:srgbClr val="3C3C3C"/>
+              <a:defRPr sz="1400">
+                <a:latin typeface="Calibri"/>
+              </a:defRPr>
+            </a:pPr>
+            <a:r>
+              <a:rPr>
+                <a:solidFill>
+                  <a:srgbClr val="323232"/>
                 </a:solidFill>
               </a:rPr>
               <a:t>  - NVIDIA T4 GPU (Google Colab free tier used).</a:t>
@@ -7703,14 +7701,14 @@
               <a:spcBef>
                 <a:spcPts val="500"/>
               </a:spcBef>
-              <a:defRPr sz="1200">
-                <a:latin typeface="Calibri"/>
-              </a:defRPr>
-            </a:pPr>
-            <a:r>
-              <a:rPr>
-                <a:solidFill>
-                  <a:srgbClr val="3C3C3C"/>
+              <a:defRPr sz="1400">
+                <a:latin typeface="Calibri"/>
+              </a:defRPr>
+            </a:pPr>
+            <a:r>
+              <a:rPr>
+                <a:solidFill>
+                  <a:srgbClr val="323232"/>
                 </a:solidFill>
               </a:rPr>
               <a:t>  - Critical for batch training of EfficientNetB0.</a:t>
@@ -7721,14 +7719,14 @@
               <a:spcBef>
                 <a:spcPts val="500"/>
               </a:spcBef>
-              <a:defRPr sz="1300">
-                <a:latin typeface="Calibri"/>
-              </a:defRPr>
-            </a:pPr>
-            <a:r>
-              <a:rPr>
-                <a:solidFill>
-                  <a:srgbClr val="3C3C3C"/>
+              <a:defRPr sz="1600">
+                <a:latin typeface="Calibri"/>
+              </a:defRPr>
+            </a:pPr>
+            <a:r>
+              <a:rPr>
+                <a:solidFill>
+                  <a:srgbClr val="323232"/>
                 </a:solidFill>
               </a:rPr>
               <a:t/>
@@ -7744,7 +7742,7 @@
             <a:r>
               <a:rPr>
                 <a:solidFill>
-                  <a:srgbClr val="3C3C3C"/>
+                  <a:srgbClr val="323232"/>
                 </a:solidFill>
               </a:rPr>
               <a:t/>
@@ -7755,14 +7753,14 @@
               <a:spcBef>
                 <a:spcPts val="500"/>
               </a:spcBef>
-              <a:defRPr sz="1200">
-                <a:latin typeface="Calibri"/>
-              </a:defRPr>
-            </a:pPr>
-            <a:r>
-              <a:rPr>
-                <a:solidFill>
-                  <a:srgbClr val="3C3C3C"/>
+              <a:defRPr sz="1400">
+                <a:latin typeface="Calibri"/>
+              </a:defRPr>
+            </a:pPr>
+            <a:r>
+              <a:rPr>
+                <a:solidFill>
+                  <a:srgbClr val="323232"/>
                 </a:solidFill>
               </a:rPr>
               <a:t>  - Deployed Space runs on a basic, free CPU instance.</a:t>
@@ -7773,14 +7771,14 @@
               <a:spcBef>
                 <a:spcPts val="500"/>
               </a:spcBef>
-              <a:defRPr sz="1200">
-                <a:latin typeface="Calibri"/>
-              </a:defRPr>
-            </a:pPr>
-            <a:r>
-              <a:rPr>
-                <a:solidFill>
-                  <a:srgbClr val="3C3C3C"/>
+              <a:defRPr sz="1400">
+                <a:latin typeface="Calibri"/>
+              </a:defRPr>
+            </a:pPr>
+            <a:r>
+              <a:rPr>
+                <a:solidFill>
+                  <a:srgbClr val="323232"/>
                 </a:solidFill>
               </a:rPr>
               <a:t>  - Made possible by replacing TensorFlow with ONNX Runtime.</a:t>
@@ -7791,14 +7789,14 @@
               <a:spcBef>
                 <a:spcPts val="500"/>
               </a:spcBef>
-              <a:defRPr sz="1300">
-                <a:latin typeface="Calibri"/>
-              </a:defRPr>
-            </a:pPr>
-            <a:r>
-              <a:rPr>
-                <a:solidFill>
-                  <a:srgbClr val="3C3C3C"/>
+              <a:defRPr sz="1600">
+                <a:latin typeface="Calibri"/>
+              </a:defRPr>
+            </a:pPr>
+            <a:r>
+              <a:rPr>
+                <a:solidFill>
+                  <a:srgbClr val="323232"/>
                 </a:solidFill>
               </a:rPr>
               <a:t/>
@@ -7814,7 +7812,7 @@
             <a:r>
               <a:rPr>
                 <a:solidFill>
-                  <a:srgbClr val="3C3C3C"/>
+                  <a:srgbClr val="323232"/>
                 </a:solidFill>
               </a:rPr>
               <a:t/>
@@ -7825,14 +7823,14 @@
               <a:spcBef>
                 <a:spcPts val="500"/>
               </a:spcBef>
-              <a:defRPr sz="1200">
-                <a:latin typeface="Calibri"/>
-              </a:defRPr>
-            </a:pPr>
-            <a:r>
-              <a:rPr>
-                <a:solidFill>
-                  <a:srgbClr val="3C3C3C"/>
+              <a:defRPr sz="1400">
+                <a:latin typeface="Calibri"/>
+              </a:defRPr>
+            </a:pPr>
+            <a:r>
+              <a:rPr>
+                <a:solidFill>
+                  <a:srgbClr val="323232"/>
                 </a:solidFill>
               </a:rPr>
               <a:t>  - Minimum: 8 GB (12 GB+ on Colab container).</a:t>
@@ -7843,14 +7841,14 @@
               <a:spcBef>
                 <a:spcPts val="500"/>
               </a:spcBef>
-              <a:defRPr sz="1300">
-                <a:latin typeface="Calibri"/>
-              </a:defRPr>
-            </a:pPr>
-            <a:r>
-              <a:rPr>
-                <a:solidFill>
-                  <a:srgbClr val="3C3C3C"/>
+              <a:defRPr sz="1600">
+                <a:latin typeface="Calibri"/>
+              </a:defRPr>
+            </a:pPr>
+            <a:r>
+              <a:rPr>
+                <a:solidFill>
+                  <a:srgbClr val="323232"/>
                 </a:solidFill>
               </a:rPr>
               <a:t/>
@@ -7866,7 +7864,7 @@
             <a:r>
               <a:rPr>
                 <a:solidFill>
-                  <a:srgbClr val="3C3C3C"/>
+                  <a:srgbClr val="323232"/>
                 </a:solidFill>
               </a:rPr>
               <a:t/>
@@ -7877,14 +7875,14 @@
               <a:spcBef>
                 <a:spcPts val="500"/>
               </a:spcBef>
-              <a:defRPr sz="1200">
-                <a:latin typeface="Calibri"/>
-              </a:defRPr>
-            </a:pPr>
-            <a:r>
-              <a:rPr>
-                <a:solidFill>
-                  <a:srgbClr val="3C3C3C"/>
+              <a:defRPr sz="1400">
+                <a:latin typeface="Calibri"/>
+              </a:defRPr>
+            </a:pPr>
+            <a:r>
+              <a:rPr>
+                <a:solidFill>
+                  <a:srgbClr val="323232"/>
                 </a:solidFill>
               </a:rPr>
               <a:t>  - ~2 GB for raw dataset download.</a:t>
@@ -7933,7 +7931,7 @@
           <a:lstStyle/>
           <a:p>
             <a:pPr>
-              <a:defRPr sz="2800" b="1">
+              <a:defRPr sz="3600" b="1">
                 <a:solidFill>
                   <a:srgbClr val="003366"/>
                 </a:solidFill>
@@ -7954,8 +7952,8 @@
         </p:nvSpPr>
         <p:spPr>
           <a:xfrm>
-            <a:off x="731520" y="1097280"/>
-            <a:ext cx="10728655" cy="18288"/>
+            <a:off x="731520" y="1188720"/>
+            <a:ext cx="10728655" cy="27432"/>
           </a:xfrm>
           <a:prstGeom prst="rect">
             <a:avLst/>
@@ -8014,7 +8012,7 @@
           <a:lstStyle/>
           <a:p>
             <a:pPr algn="r">
-              <a:defRPr sz="1000">
+              <a:defRPr sz="1200">
                 <a:solidFill>
                   <a:srgbClr val="808080"/>
                 </a:solidFill>
@@ -8050,7 +8048,7 @@
           <a:lstStyle/>
           <a:p>
             <a:pPr>
-              <a:defRPr sz="1600" b="1">
+              <a:defRPr sz="2000" b="1">
                 <a:solidFill>
                   <a:srgbClr val="003366"/>
                 </a:solidFill>
@@ -8064,16 +8062,16 @@
           <a:p>
             <a:pPr>
               <a:spcBef>
-                <a:spcPts val="400"/>
-              </a:spcBef>
-              <a:defRPr sz="1300">
-                <a:latin typeface="Calibri"/>
-              </a:defRPr>
-            </a:pPr>
-            <a:r>
-              <a:rPr>
-                <a:solidFill>
-                  <a:srgbClr val="3C3C3C"/>
+                <a:spcPts val="600"/>
+              </a:spcBef>
+              <a:defRPr sz="1600">
+                <a:latin typeface="Calibri"/>
+              </a:defRPr>
+            </a:pPr>
+            <a:r>
+              <a:rPr>
+                <a:solidFill>
+                  <a:srgbClr val="323232"/>
                 </a:solidFill>
               </a:rPr>
               <a:t>Uses </a:t>
@@ -8089,7 +8087,7 @@
             <a:r>
               <a:rPr>
                 <a:solidFill>
-                  <a:srgbClr val="3C3C3C"/>
+                  <a:srgbClr val="323232"/>
                 </a:solidFill>
               </a:rPr>
               <a:t> as a frozen/partially-frozen feature extractor. EfficientNet is chosen due to its high efficiency and parameter balance (5.3M parameters vs. 25.6M for ResNet50).</a:t>
@@ -8098,16 +8096,16 @@
           <a:p>
             <a:pPr>
               <a:spcBef>
-                <a:spcPts val="400"/>
-              </a:spcBef>
-              <a:defRPr sz="1300">
-                <a:latin typeface="Calibri"/>
-              </a:defRPr>
-            </a:pPr>
-            <a:r>
-              <a:rPr>
-                <a:solidFill>
-                  <a:srgbClr val="3C3C3C"/>
+                <a:spcPts val="600"/>
+              </a:spcBef>
+              <a:defRPr sz="1600">
+                <a:latin typeface="Calibri"/>
+              </a:defRPr>
+            </a:pPr>
+            <a:r>
+              <a:rPr>
+                <a:solidFill>
+                  <a:srgbClr val="323232"/>
                 </a:solidFill>
               </a:rPr>
               <a:t>A customized dense classification head is added on top to support the 4 brain tumor classes.</a:t>
@@ -8124,7 +8122,7 @@
         <p:spPr>
           <a:xfrm>
             <a:off x="731520" y="2926080"/>
-            <a:ext cx="1554480" cy="1645920"/>
+            <a:ext cx="1554480" cy="2011680"/>
           </a:xfrm>
           <a:prstGeom prst="roundRect">
             <a:avLst/>
@@ -8132,7 +8130,7 @@
           <a:solidFill>
             <a:srgbClr val="E6F0FF"/>
           </a:solidFill>
-          <a:ln w="19050">
+          <a:ln w="25400">
             <a:solidFill>
               <a:srgbClr val="003366"/>
             </a:solidFill>
@@ -8158,9 +8156,9 @@
           <a:p>
             <a:pPr algn="ctr">
               <a:spcBef>
-                <a:spcPts val="1000"/>
-              </a:spcBef>
-              <a:defRPr sz="1100" b="1">
+                <a:spcPts val="1500"/>
+              </a:spcBef>
+              <a:defRPr sz="1400" b="1">
                 <a:solidFill>
                   <a:srgbClr val="003366"/>
                 </a:solidFill>
@@ -8185,7 +8183,7 @@
         </p:nvSpPr>
         <p:spPr>
           <a:xfrm>
-            <a:off x="2286000" y="3474720"/>
+            <a:off x="2286000" y="3657600"/>
             <a:ext cx="274320" cy="548640"/>
           </a:xfrm>
           <a:prstGeom prst="rect">
@@ -8200,7 +8198,7 @@
           <a:lstStyle/>
           <a:p>
             <a:pPr algn="ctr">
-              <a:defRPr sz="2000">
+              <a:defRPr sz="2400">
                 <a:solidFill>
                   <a:srgbClr val="4682B4"/>
                 </a:solidFill>
@@ -8221,7 +8219,7 @@
         <p:spPr>
           <a:xfrm>
             <a:off x="2560320" y="2926080"/>
-            <a:ext cx="1554480" cy="1645920"/>
+            <a:ext cx="1554480" cy="2011680"/>
           </a:xfrm>
           <a:prstGeom prst="roundRect">
             <a:avLst/>
@@ -8229,7 +8227,7 @@
           <a:solidFill>
             <a:srgbClr val="E6F0FF"/>
           </a:solidFill>
-          <a:ln w="19050">
+          <a:ln w="25400">
             <a:solidFill>
               <a:srgbClr val="003366"/>
             </a:solidFill>
@@ -8255,9 +8253,9 @@
           <a:p>
             <a:pPr algn="ctr">
               <a:spcBef>
-                <a:spcPts val="1000"/>
-              </a:spcBef>
-              <a:defRPr sz="1100" b="1">
+                <a:spcPts val="1500"/>
+              </a:spcBef>
+              <a:defRPr sz="1400" b="1">
                 <a:solidFill>
                   <a:srgbClr val="003366"/>
                 </a:solidFill>
@@ -8282,7 +8280,7 @@
         </p:nvSpPr>
         <p:spPr>
           <a:xfrm>
-            <a:off x="4114800" y="3474720"/>
+            <a:off x="4114800" y="3657600"/>
             <a:ext cx="274320" cy="548640"/>
           </a:xfrm>
           <a:prstGeom prst="rect">
@@ -8297,7 +8295,7 @@
           <a:lstStyle/>
           <a:p>
             <a:pPr algn="ctr">
-              <a:defRPr sz="2000">
+              <a:defRPr sz="2400">
                 <a:solidFill>
                   <a:srgbClr val="4682B4"/>
                 </a:solidFill>
@@ -8318,7 +8316,7 @@
         <p:spPr>
           <a:xfrm>
             <a:off x="4389120" y="2926080"/>
-            <a:ext cx="1554480" cy="1645920"/>
+            <a:ext cx="1554480" cy="2011680"/>
           </a:xfrm>
           <a:prstGeom prst="roundRect">
             <a:avLst/>
@@ -8326,7 +8324,7 @@
           <a:solidFill>
             <a:srgbClr val="E6F0FF"/>
           </a:solidFill>
-          <a:ln w="19050">
+          <a:ln w="25400">
             <a:solidFill>
               <a:srgbClr val="003366"/>
             </a:solidFill>
@@ -8352,9 +8350,9 @@
           <a:p>
             <a:pPr algn="ctr">
               <a:spcBef>
-                <a:spcPts val="1000"/>
-              </a:spcBef>
-              <a:defRPr sz="1100" b="1">
+                <a:spcPts val="1500"/>
+              </a:spcBef>
+              <a:defRPr sz="1400" b="1">
                 <a:solidFill>
                   <a:srgbClr val="003366"/>
                 </a:solidFill>
@@ -8379,7 +8377,7 @@
         </p:nvSpPr>
         <p:spPr>
           <a:xfrm>
-            <a:off x="5943600" y="3474720"/>
+            <a:off x="5943600" y="3657600"/>
             <a:ext cx="274320" cy="548640"/>
           </a:xfrm>
           <a:prstGeom prst="rect">
@@ -8394,7 +8392,7 @@
           <a:lstStyle/>
           <a:p>
             <a:pPr algn="ctr">
-              <a:defRPr sz="2000">
+              <a:defRPr sz="2400">
                 <a:solidFill>
                   <a:srgbClr val="4682B4"/>
                 </a:solidFill>
@@ -8415,7 +8413,7 @@
         <p:spPr>
           <a:xfrm>
             <a:off x="6217920" y="2926080"/>
-            <a:ext cx="1554480" cy="1645920"/>
+            <a:ext cx="1554480" cy="2011680"/>
           </a:xfrm>
           <a:prstGeom prst="roundRect">
             <a:avLst/>
@@ -8423,7 +8421,7 @@
           <a:solidFill>
             <a:srgbClr val="E6F0FF"/>
           </a:solidFill>
-          <a:ln w="19050">
+          <a:ln w="25400">
             <a:solidFill>
               <a:srgbClr val="003366"/>
             </a:solidFill>
@@ -8449,9 +8447,9 @@
           <a:p>
             <a:pPr algn="ctr">
               <a:spcBef>
-                <a:spcPts val="1000"/>
-              </a:spcBef>
-              <a:defRPr sz="1100" b="1">
+                <a:spcPts val="1500"/>
+              </a:spcBef>
+              <a:defRPr sz="1400" b="1">
                 <a:solidFill>
                   <a:srgbClr val="003366"/>
                 </a:solidFill>
@@ -8476,7 +8474,7 @@
         </p:nvSpPr>
         <p:spPr>
           <a:xfrm>
-            <a:off x="7772400" y="3474720"/>
+            <a:off x="7772400" y="3657600"/>
             <a:ext cx="274320" cy="548640"/>
           </a:xfrm>
           <a:prstGeom prst="rect">
@@ -8491,7 +8489,7 @@
           <a:lstStyle/>
           <a:p>
             <a:pPr algn="ctr">
-              <a:defRPr sz="2000">
+              <a:defRPr sz="2400">
                 <a:solidFill>
                   <a:srgbClr val="4682B4"/>
                 </a:solidFill>
@@ -8512,7 +8510,7 @@
         <p:spPr>
           <a:xfrm>
             <a:off x="8046720" y="2926080"/>
-            <a:ext cx="1554480" cy="1645920"/>
+            <a:ext cx="1554480" cy="2011680"/>
           </a:xfrm>
           <a:prstGeom prst="roundRect">
             <a:avLst/>
@@ -8520,7 +8518,7 @@
           <a:solidFill>
             <a:srgbClr val="E6F0FF"/>
           </a:solidFill>
-          <a:ln w="19050">
+          <a:ln w="25400">
             <a:solidFill>
               <a:srgbClr val="003366"/>
             </a:solidFill>
@@ -8546,9 +8544,9 @@
           <a:p>
             <a:pPr algn="ctr">
               <a:spcBef>
-                <a:spcPts val="1000"/>
-              </a:spcBef>
-              <a:defRPr sz="1100" b="1">
+                <a:spcPts val="1500"/>
+              </a:spcBef>
+              <a:defRPr sz="1400" b="1">
                 <a:solidFill>
                   <a:srgbClr val="003366"/>
                 </a:solidFill>
@@ -8573,7 +8571,7 @@
         </p:nvSpPr>
         <p:spPr>
           <a:xfrm>
-            <a:off x="9601200" y="3474720"/>
+            <a:off x="9601200" y="3657600"/>
             <a:ext cx="274320" cy="548640"/>
           </a:xfrm>
           <a:prstGeom prst="rect">
@@ -8588,7 +8586,7 @@
           <a:lstStyle/>
           <a:p>
             <a:pPr algn="ctr">
-              <a:defRPr sz="2000">
+              <a:defRPr sz="2400">
                 <a:solidFill>
                   <a:srgbClr val="4682B4"/>
                 </a:solidFill>
@@ -8609,7 +8607,7 @@
         <p:spPr>
           <a:xfrm>
             <a:off x="9875520" y="2926080"/>
-            <a:ext cx="1554480" cy="1645920"/>
+            <a:ext cx="1554480" cy="2011680"/>
           </a:xfrm>
           <a:prstGeom prst="roundRect">
             <a:avLst/>
@@ -8617,7 +8615,7 @@
           <a:solidFill>
             <a:srgbClr val="E6F0FF"/>
           </a:solidFill>
-          <a:ln w="19050">
+          <a:ln w="25400">
             <a:solidFill>
               <a:srgbClr val="003366"/>
             </a:solidFill>
@@ -8643,9 +8641,9 @@
           <a:p>
             <a:pPr algn="ctr">
               <a:spcBef>
-                <a:spcPts val="1000"/>
-              </a:spcBef>
-              <a:defRPr sz="1100" b="1">
+                <a:spcPts val="1500"/>
+              </a:spcBef>
+              <a:defRPr sz="1400" b="1">
                 <a:solidFill>
                   <a:srgbClr val="003366"/>
                 </a:solidFill>
@@ -8703,7 +8701,7 @@
           <a:lstStyle/>
           <a:p>
             <a:pPr>
-              <a:defRPr sz="2800" b="1">
+              <a:defRPr sz="3600" b="1">
                 <a:solidFill>
                   <a:srgbClr val="003366"/>
                 </a:solidFill>
@@ -8724,8 +8722,8 @@
         </p:nvSpPr>
         <p:spPr>
           <a:xfrm>
-            <a:off x="731520" y="1097280"/>
-            <a:ext cx="10728655" cy="18288"/>
+            <a:off x="731520" y="1188720"/>
+            <a:ext cx="10728655" cy="27432"/>
           </a:xfrm>
           <a:prstGeom prst="rect">
             <a:avLst/>
@@ -8784,7 +8782,7 @@
           <a:lstStyle/>
           <a:p>
             <a:pPr algn="r">
-              <a:defRPr sz="1000">
+              <a:defRPr sz="1200">
                 <a:solidFill>
                   <a:srgbClr val="808080"/>
                 </a:solidFill>
@@ -8823,14 +8821,14 @@
               <a:spcBef>
                 <a:spcPts val="500"/>
               </a:spcBef>
-              <a:defRPr sz="1350">
-                <a:latin typeface="Calibri"/>
-              </a:defRPr>
-            </a:pPr>
-            <a:r>
-              <a:rPr>
-                <a:solidFill>
-                  <a:srgbClr val="3C3C3C"/>
+              <a:defRPr sz="1600">
+                <a:latin typeface="Calibri"/>
+              </a:defRPr>
+            </a:pPr>
+            <a:r>
+              <a:rPr>
+                <a:solidFill>
+                  <a:srgbClr val="323232"/>
                 </a:solidFill>
               </a:rPr>
               <a:t/>
@@ -8846,7 +8844,7 @@
             <a:r>
               <a:rPr>
                 <a:solidFill>
-                  <a:srgbClr val="3C3C3C"/>
+                  <a:srgbClr val="323232"/>
                 </a:solidFill>
               </a:rPr>
               <a:t> Successfully implemented a two-phase transfer learning framework achieving stable learning curves.</a:t>
@@ -8857,14 +8855,14 @@
               <a:spcBef>
                 <a:spcPts val="500"/>
               </a:spcBef>
-              <a:defRPr sz="1350">
-                <a:latin typeface="Calibri"/>
-              </a:defRPr>
-            </a:pPr>
-            <a:r>
-              <a:rPr>
-                <a:solidFill>
-                  <a:srgbClr val="3C3C3C"/>
+              <a:defRPr sz="1600">
+                <a:latin typeface="Calibri"/>
+              </a:defRPr>
+            </a:pPr>
+            <a:r>
+              <a:rPr>
+                <a:solidFill>
+                  <a:srgbClr val="323232"/>
                 </a:solidFill>
               </a:rPr>
               <a:t/>
@@ -8880,7 +8878,7 @@
             <a:r>
               <a:rPr>
                 <a:solidFill>
-                  <a:srgbClr val="3C3C3C"/>
+                  <a:srgbClr val="323232"/>
                 </a:solidFill>
               </a:rPr>
               <a:t/>
@@ -8891,14 +8889,14 @@
               <a:spcBef>
                 <a:spcPts val="500"/>
               </a:spcBef>
-              <a:defRPr sz="1150">
-                <a:latin typeface="Calibri"/>
-              </a:defRPr>
-            </a:pPr>
-            <a:r>
-              <a:rPr>
-                <a:solidFill>
-                  <a:srgbClr val="3C3C3C"/>
+              <a:defRPr sz="1300">
+                <a:latin typeface="Calibri"/>
+              </a:defRPr>
+            </a:pPr>
+            <a:r>
+              <a:rPr>
+                <a:solidFill>
+                  <a:srgbClr val="323232"/>
                 </a:solidFill>
               </a:rPr>
               <a:t>  - </a:t>
@@ -8914,7 +8912,7 @@
             <a:r>
               <a:rPr>
                 <a:solidFill>
-                  <a:srgbClr val="3C3C3C"/>
+                  <a:srgbClr val="323232"/>
                 </a:solidFill>
               </a:rPr>
               <a:t> ImageDataGenerator `rescale=1./255` was double-scaling inputs since EfficientNetB0 has its own internal Rescaling layer.</a:t>
@@ -8925,14 +8923,14 @@
               <a:spcBef>
                 <a:spcPts val="500"/>
               </a:spcBef>
-              <a:defRPr sz="1150">
-                <a:latin typeface="Calibri"/>
-              </a:defRPr>
-            </a:pPr>
-            <a:r>
-              <a:rPr>
-                <a:solidFill>
-                  <a:srgbClr val="3C3C3C"/>
+              <a:defRPr sz="1300">
+                <a:latin typeface="Calibri"/>
+              </a:defRPr>
+            </a:pPr>
+            <a:r>
+              <a:rPr>
+                <a:solidFill>
+                  <a:srgbClr val="323232"/>
                 </a:solidFill>
               </a:rPr>
               <a:t>  - </a:t>
@@ -8948,7 +8946,7 @@
             <a:r>
               <a:rPr>
                 <a:solidFill>
-                  <a:srgbClr val="3C3C3C"/>
+                  <a:srgbClr val="323232"/>
                 </a:solidFill>
               </a:rPr>
               <a:t> Vanishing gradients resulted in model predicting only the majority class ('No Tumor').</a:t>
@@ -8959,14 +8957,14 @@
               <a:spcBef>
                 <a:spcPts val="500"/>
               </a:spcBef>
-              <a:defRPr sz="1150">
-                <a:latin typeface="Calibri"/>
-              </a:defRPr>
-            </a:pPr>
-            <a:r>
-              <a:rPr>
-                <a:solidFill>
-                  <a:srgbClr val="3C3C3C"/>
+              <a:defRPr sz="1300">
+                <a:latin typeface="Calibri"/>
+              </a:defRPr>
+            </a:pPr>
+            <a:r>
+              <a:rPr>
+                <a:solidFill>
+                  <a:srgbClr val="323232"/>
                 </a:solidFill>
               </a:rPr>
               <a:t>  - </a:t>
@@ -8982,7 +8980,7 @@
             <a:r>
               <a:rPr>
                 <a:solidFill>
-                  <a:srgbClr val="3C3C3C"/>
+                  <a:srgbClr val="323232"/>
                 </a:solidFill>
               </a:rPr>
               <a:t> Removed manual scaling, passing raw [0, 255] ranges, which completely restored accuracy.</a:t>
@@ -8993,14 +8991,14 @@
               <a:spcBef>
                 <a:spcPts val="500"/>
               </a:spcBef>
-              <a:defRPr sz="1350">
-                <a:latin typeface="Calibri"/>
-              </a:defRPr>
-            </a:pPr>
-            <a:r>
-              <a:rPr>
-                <a:solidFill>
-                  <a:srgbClr val="3C3C3C"/>
+              <a:defRPr sz="1600">
+                <a:latin typeface="Calibri"/>
+              </a:defRPr>
+            </a:pPr>
+            <a:r>
+              <a:rPr>
+                <a:solidFill>
+                  <a:srgbClr val="323232"/>
                 </a:solidFill>
               </a:rPr>
               <a:t/>
@@ -9016,7 +9014,7 @@
             <a:r>
               <a:rPr>
                 <a:solidFill>
-                  <a:srgbClr val="3C3C3C"/>
+                  <a:srgbClr val="323232"/>
                 </a:solidFill>
               </a:rPr>
               <a:t> Achieved </a:t>
@@ -9032,7 +9030,7 @@
             <a:r>
               <a:rPr>
                 <a:solidFill>
-                  <a:srgbClr val="3C3C3C"/>
+                  <a:srgbClr val="323232"/>
                 </a:solidFill>
               </a:rPr>
               <a:t> and </a:t>
@@ -9048,7 +9046,7 @@
             <a:r>
               <a:rPr>
                 <a:solidFill>
-                  <a:srgbClr val="3C3C3C"/>
+                  <a:srgbClr val="323232"/>
                 </a:solidFill>
               </a:rPr>
               <a:t>.</a:t>
@@ -9059,14 +9057,14 @@
               <a:spcBef>
                 <a:spcPts val="500"/>
               </a:spcBef>
-              <a:defRPr sz="1350">
-                <a:latin typeface="Calibri"/>
-              </a:defRPr>
-            </a:pPr>
-            <a:r>
-              <a:rPr>
-                <a:solidFill>
-                  <a:srgbClr val="3C3C3C"/>
+              <a:defRPr sz="1600">
+                <a:latin typeface="Calibri"/>
+              </a:defRPr>
+            </a:pPr>
+            <a:r>
+              <a:rPr>
+                <a:solidFill>
+                  <a:srgbClr val="323232"/>
                 </a:solidFill>
               </a:rPr>
               <a:t/>
@@ -9082,7 +9080,7 @@
             <a:r>
               <a:rPr>
                 <a:solidFill>
-                  <a:srgbClr val="3C3C3C"/>
+                  <a:srgbClr val="323232"/>
                 </a:solidFill>
               </a:rPr>
               <a:t> Exchanged the massive TensorFlow library for the lightweight </a:t>
@@ -9098,7 +9096,7 @@
             <a:r>
               <a:rPr>
                 <a:solidFill>
-                  <a:srgbClr val="3C3C3C"/>
+                  <a:srgbClr val="323232"/>
                 </a:solidFill>
               </a:rPr>
               <a:t>, shrinking the production model to just </a:t>
@@ -9114,7 +9112,7 @@
             <a:r>
               <a:rPr>
                 <a:solidFill>
-                  <a:srgbClr val="3C3C3C"/>
+                  <a:srgbClr val="323232"/>
                 </a:solidFill>
               </a:rPr>
               <a:t>.</a:t>
@@ -9145,7 +9143,7 @@
           <a:lstStyle/>
           <a:p>
             <a:pPr algn="ctr">
-              <a:defRPr sz="1150" b="1">
+              <a:defRPr sz="1400" b="1">
                 <a:solidFill>
                   <a:srgbClr val="003366"/>
                 </a:solidFill>
@@ -9174,7 +9172,7 @@
         </p:blipFill>
         <p:spPr>
           <a:xfrm>
-            <a:off x="6217920" y="1463040"/>
+            <a:off x="6217920" y="1554480"/>
             <a:ext cx="5212080" cy="2011680"/>
           </a:xfrm>
           <a:prstGeom prst="rect">
@@ -9190,7 +9188,7 @@
         </p:nvSpPr>
         <p:spPr>
           <a:xfrm>
-            <a:off x="6217920" y="3566160"/>
+            <a:off x="6217920" y="3657600"/>
             <a:ext cx="5212080" cy="274320"/>
           </a:xfrm>
           <a:prstGeom prst="rect">
@@ -9205,7 +9203,7 @@
           <a:lstStyle/>
           <a:p>
             <a:pPr algn="ctr">
-              <a:defRPr sz="1150" b="1">
+              <a:defRPr sz="1400" b="1">
                 <a:solidFill>
                   <a:srgbClr val="003366"/>
                 </a:solidFill>
@@ -9234,7 +9232,7 @@
         </p:blipFill>
         <p:spPr>
           <a:xfrm>
-            <a:off x="6217920" y="3840480"/>
+            <a:off x="6217920" y="4023360"/>
             <a:ext cx="5212080" cy="2011680"/>
           </a:xfrm>
           <a:prstGeom prst="rect">

</xml_diff>